<commit_message>
Streamline Pod 00 prerequisites deck from 28 to 20 slides
Rewrote the Claude Code setup section with 3 clear starting points,
added Warp install instructions, consolidated duplicate troubleshooting
tables into one, and trimmed verbose slides for a crisper presentation.

Co-Authored-By: Claude Opus 4.6 (1M context) <noreply@anthropic.com>
</commit_message>
<xml_diff>
--- a/pods/00-prerequisites/README.pptx
+++ b/pods/00-prerequisites/README.pptx
@@ -25,16 +25,6 @@
     <p:sldId id="273" r:id="rId24"/>
     <p:sldId id="274" r:id="rId25"/>
     <p:sldId id="275" r:id="rId26"/>
-    <p:sldId id="276" r:id="rId27"/>
-    <p:sldId id="277" r:id="rId28"/>
-    <p:sldId id="278" r:id="rId29"/>
-    <p:sldId id="279" r:id="rId30"/>
-    <p:sldId id="280" r:id="rId31"/>
-    <p:sldId id="281" r:id="rId32"/>
-    <p:sldId id="282" r:id="rId33"/>
-    <p:sldId id="283" r:id="rId34"/>
-    <p:sldId id="284" r:id="rId35"/>
-    <p:sldId id="285" r:id="rId36"/>
   </p:sldIdLst>
   <p:sldSz cx="12191695" cy="6858000" type="screen4x3"/>
   <p:notesSz cx="6858000" cy="9144000"/>
@@ -3305,8 +3295,8 @@
         </p:nvSpPr>
         <p:spPr>
           <a:xfrm>
-            <a:off x="914400" y="2560320"/>
-            <a:ext cx="10362895" cy="1371600"/>
+            <a:off x="731520" y="365760"/>
+            <a:ext cx="10728655" cy="914400"/>
           </a:xfrm>
           <a:prstGeom prst="rect">
             <a:avLst/>
@@ -3314,67 +3304,248 @@
           <a:noFill/>
         </p:spPr>
         <p:txBody>
-          <a:bodyPr wrap="square">
-            <a:spAutoFit/>
-          </a:bodyPr>
-          <a:lstStyle/>
-          <a:p>
-            <a:pPr algn="ctr"/>
-            <a:r>
-              <a:rPr sz="3200" b="1" i="0">
+          <a:bodyPr wrap="square"/>
+          <a:lstStyle/>
+          <a:p>
+            <a:pPr algn="l"/>
+            <a:r>
+              <a:rPr sz="2800" b="1" i="0">
                 <a:solidFill>
                   <a:srgbClr val="FFFFFF"/>
                 </a:solidFill>
                 <a:latin typeface="Lato"/>
               </a:rPr>
-              <a:t>Path A: Claude Desktop App (Fastest)</a:t>
-            </a:r>
-          </a:p>
-        </p:txBody>
-      </p:sp>
-      <p:sp>
-        <p:nvSpPr>
-          <p:cNvPr id="3" name="Rectangle 2"/>
-          <p:cNvSpPr/>
+              <a:t>Step 3: Pick Your Starting Point</a:t>
+            </a:r>
+          </a:p>
+        </p:txBody>
+      </p:sp>
+      <p:graphicFrame>
+        <p:nvGraphicFramePr>
+          <p:cNvPr id="3" name="Table 2"/>
+          <p:cNvGraphicFramePr>
+            <a:graphicFrameLocks noGrp="1"/>
+          </p:cNvGraphicFramePr>
           <p:nvPr/>
-        </p:nvSpPr>
-        <p:spPr>
-          <a:xfrm>
-            <a:off x="4724247" y="4114800"/>
-            <a:ext cx="2743200" cy="54864"/>
-          </a:xfrm>
-          <a:prstGeom prst="rect">
-            <a:avLst/>
-          </a:prstGeom>
-          <a:solidFill>
-            <a:srgbClr val="4A90D9"/>
-          </a:solidFill>
-          <a:ln>
-            <a:noFill/>
-          </a:ln>
-        </p:spPr>
-        <p:style>
-          <a:lnRef idx="1">
-            <a:schemeClr val="accent1"/>
-          </a:lnRef>
-          <a:fillRef idx="3">
-            <a:schemeClr val="accent1"/>
-          </a:fillRef>
-          <a:effectRef idx="2">
-            <a:schemeClr val="accent1"/>
-          </a:effectRef>
-          <a:fontRef idx="minor">
-            <a:schemeClr val="lt1"/>
-          </a:fontRef>
-        </p:style>
-        <p:txBody>
-          <a:bodyPr rtlCol="0" anchor="ctr"/>
-          <a:lstStyle/>
-          <a:p>
-            <a:pPr algn="ctr"/>
-          </a:p>
-        </p:txBody>
-      </p:sp>
+        </p:nvGraphicFramePr>
+        <p:xfrm>
+          <a:off x="731520" y="1645920"/>
+          <a:ext cx="10728655" cy="1645920"/>
+        </p:xfrm>
+        <a:graphic>
+          <a:graphicData uri="http://schemas.openxmlformats.org/drawingml/2006/table">
+            <a:tbl>
+              <a:tblPr firstRow="1" bandRow="1">
+                <a:tableStyleId>{5C22544A-7EE6-4342-B048-85BDC9FD1C3A}</a:tableStyleId>
+              </a:tblPr>
+              <a:tblGrid>
+                <a:gridCol w="5364327"/>
+                <a:gridCol w="5364328"/>
+              </a:tblGrid>
+              <a:tr h="411480">
+                <a:tc>
+                  <a:txBody>
+                    <a:bodyPr/>
+                    <a:lstStyle/>
+                    <a:p>
+                      <a:pPr>
+                        <a:defRPr sz="1400" b="1">
+                          <a:solidFill>
+                            <a:srgbClr val="FFFFFF"/>
+                          </a:solidFill>
+                          <a:latin typeface="Lato"/>
+                        </a:defRPr>
+                      </a:pPr>
+                      <a:r>
+                        <a:t>Situation</a:t>
+                      </a:r>
+                    </a:p>
+                  </a:txBody>
+                  <a:tcPr>
+                    <a:solidFill>
+                      <a:srgbClr val="1E2C56"/>
+                    </a:solidFill>
+                  </a:tcPr>
+                </a:tc>
+                <a:tc>
+                  <a:txBody>
+                    <a:bodyPr/>
+                    <a:lstStyle/>
+                    <a:p>
+                      <a:pPr>
+                        <a:defRPr sz="1400" b="1">
+                          <a:solidFill>
+                            <a:srgbClr val="FFFFFF"/>
+                          </a:solidFill>
+                          <a:latin typeface="Lato"/>
+                        </a:defRPr>
+                      </a:pPr>
+                      <a:r>
+                        <a:t>Path</a:t>
+                      </a:r>
+                    </a:p>
+                  </a:txBody>
+                  <a:tcPr>
+                    <a:solidFill>
+                      <a:srgbClr val="1E2C56"/>
+                    </a:solidFill>
+                  </a:tcPr>
+                </a:tc>
+              </a:tr>
+              <a:tr h="411480">
+                <a:tc>
+                  <a:txBody>
+                    <a:bodyPr/>
+                    <a:lstStyle/>
+                    <a:p>
+                      <a:pPr>
+                        <a:defRPr sz="1200">
+                          <a:solidFill>
+                            <a:srgbClr val="E0E0E0"/>
+                          </a:solidFill>
+                          <a:latin typeface="Lato"/>
+                        </a:defRPr>
+                      </a:pPr>
+                      <a:r>
+                        <a:t>I can type `claude` in Warp and it works</a:t>
+                      </a:r>
+                    </a:p>
+                  </a:txBody>
+                  <a:tcPr>
+                    <a:solidFill>
+                      <a:srgbClr val="16213E"/>
+                    </a:solidFill>
+                  </a:tcPr>
+                </a:tc>
+                <a:tc>
+                  <a:txBody>
+                    <a:bodyPr/>
+                    <a:lstStyle/>
+                    <a:p>
+                      <a:pPr>
+                        <a:defRPr sz="1200">
+                          <a:solidFill>
+                            <a:srgbClr val="E0E0E0"/>
+                          </a:solidFill>
+                          <a:latin typeface="Lato"/>
+                        </a:defRPr>
+                      </a:pPr>
+                      <a:r>
+                        <a:t>Path 1 — Done!</a:t>
+                      </a:r>
+                    </a:p>
+                  </a:txBody>
+                  <a:tcPr>
+                    <a:solidFill>
+                      <a:srgbClr val="16213E"/>
+                    </a:solidFill>
+                  </a:tcPr>
+                </a:tc>
+              </a:tr>
+              <a:tr h="411480">
+                <a:tc>
+                  <a:txBody>
+                    <a:bodyPr/>
+                    <a:lstStyle/>
+                    <a:p>
+                      <a:pPr>
+                        <a:defRPr sz="1200">
+                          <a:solidFill>
+                            <a:srgbClr val="E0E0E0"/>
+                          </a:solidFill>
+                          <a:latin typeface="Lato"/>
+                        </a:defRPr>
+                      </a:pPr>
+                      <a:r>
+                        <a:t>I have Claude Desktop but not Claude Code in terminal</a:t>
+                      </a:r>
+                    </a:p>
+                  </a:txBody>
+                  <a:tcPr>
+                    <a:solidFill>
+                      <a:srgbClr val="1A1A2E"/>
+                    </a:solidFill>
+                  </a:tcPr>
+                </a:tc>
+                <a:tc>
+                  <a:txBody>
+                    <a:bodyPr/>
+                    <a:lstStyle/>
+                    <a:p>
+                      <a:pPr>
+                        <a:defRPr sz="1200">
+                          <a:solidFill>
+                            <a:srgbClr val="E0E0E0"/>
+                          </a:solidFill>
+                          <a:latin typeface="Lato"/>
+                        </a:defRPr>
+                      </a:pPr>
+                      <a:r>
+                        <a:t>Path 2 — 5 min</a:t>
+                      </a:r>
+                    </a:p>
+                  </a:txBody>
+                  <a:tcPr>
+                    <a:solidFill>
+                      <a:srgbClr val="1A1A2E"/>
+                    </a:solidFill>
+                  </a:tcPr>
+                </a:tc>
+              </a:tr>
+              <a:tr h="411480">
+                <a:tc>
+                  <a:txBody>
+                    <a:bodyPr/>
+                    <a:lstStyle/>
+                    <a:p>
+                      <a:pPr>
+                        <a:defRPr sz="1200">
+                          <a:solidFill>
+                            <a:srgbClr val="E0E0E0"/>
+                          </a:solidFill>
+                          <a:latin typeface="Lato"/>
+                        </a:defRPr>
+                      </a:pPr>
+                      <a:r>
+                        <a:t>I don't have either</a:t>
+                      </a:r>
+                    </a:p>
+                  </a:txBody>
+                  <a:tcPr>
+                    <a:solidFill>
+                      <a:srgbClr val="16213E"/>
+                    </a:solidFill>
+                  </a:tcPr>
+                </a:tc>
+                <a:tc>
+                  <a:txBody>
+                    <a:bodyPr/>
+                    <a:lstStyle/>
+                    <a:p>
+                      <a:pPr>
+                        <a:defRPr sz="1200">
+                          <a:solidFill>
+                            <a:srgbClr val="E0E0E0"/>
+                          </a:solidFill>
+                          <a:latin typeface="Lato"/>
+                        </a:defRPr>
+                      </a:pPr>
+                      <a:r>
+                        <a:t>Path 3 — 10 min</a:t>
+                      </a:r>
+                    </a:p>
+                  </a:txBody>
+                  <a:tcPr>
+                    <a:solidFill>
+                      <a:srgbClr val="16213E"/>
+                    </a:solidFill>
+                  </a:tcPr>
+                </a:tc>
+              </a:tr>
+            </a:tbl>
+          </a:graphicData>
+        </a:graphic>
+      </p:graphicFrame>
     </p:spTree>
   </p:cSld>
   <p:clrMapOvr>
@@ -3409,8 +3580,8 @@
         </p:nvSpPr>
         <p:spPr>
           <a:xfrm>
-            <a:off x="731520" y="365760"/>
-            <a:ext cx="10728655" cy="914400"/>
+            <a:off x="914400" y="2560320"/>
+            <a:ext cx="10362895" cy="1371600"/>
           </a:xfrm>
           <a:prstGeom prst="rect">
             <a:avLst/>
@@ -3418,18 +3589,20 @@
           <a:noFill/>
         </p:spPr>
         <p:txBody>
-          <a:bodyPr wrap="square"/>
-          <a:lstStyle/>
-          <a:p>
-            <a:pPr algn="l"/>
-            <a:r>
-              <a:rPr sz="2800" b="1" i="0">
+          <a:bodyPr wrap="square">
+            <a:spAutoFit/>
+          </a:bodyPr>
+          <a:lstStyle/>
+          <a:p>
+            <a:pPr algn="ctr"/>
+            <a:r>
+              <a:rPr sz="3200" b="1" i="0">
                 <a:solidFill>
                   <a:srgbClr val="FFFFFF"/>
                 </a:solidFill>
                 <a:latin typeface="Lato"/>
               </a:rPr>
-              <a:t>Steps</a:t>
+              <a:t>Path 1: Already Have Claude Code</a:t>
             </a:r>
           </a:p>
         </p:txBody>
@@ -3442,8 +3615,8 @@
         </p:nvSpPr>
         <p:spPr>
           <a:xfrm>
-            <a:off x="5181447" y="1325880"/>
-            <a:ext cx="1828800" cy="54864"/>
+            <a:off x="4724247" y="4114800"/>
+            <a:ext cx="2743200" cy="54864"/>
           </a:xfrm>
           <a:prstGeom prst="rect">
             <a:avLst/>
@@ -3474,152 +3647,6 @@
           <a:lstStyle/>
           <a:p>
             <a:pPr algn="ctr"/>
-          </a:p>
-        </p:txBody>
-      </p:sp>
-      <p:sp>
-        <p:nvSpPr>
-          <p:cNvPr id="4" name="TextBox 3"/>
-          <p:cNvSpPr txBox="1"/>
-          <p:nvPr/>
-        </p:nvSpPr>
-        <p:spPr>
-          <a:xfrm>
-            <a:off x="731520" y="1645920"/>
-            <a:ext cx="10728655" cy="4754880"/>
-          </a:xfrm>
-          <a:prstGeom prst="rect">
-            <a:avLst/>
-          </a:prstGeom>
-          <a:noFill/>
-        </p:spPr>
-        <p:txBody>
-          <a:bodyPr wrap="square"/>
-          <a:lstStyle/>
-          <a:p>
-            <a:pPr algn="l">
-              <a:spcAft>
-                <a:spcPts val="1200"/>
-              </a:spcAft>
-            </a:pPr>
-            <a:r>
-              <a:rPr sz="1800" b="1" i="0">
-                <a:solidFill>
-                  <a:srgbClr val="4A90D9"/>
-                </a:solidFill>
-                <a:latin typeface="Lato"/>
-              </a:rPr>
-              <a:t>1.  </a:t>
-            </a:r>
-            <a:r>
-              <a:rPr sz="1800" b="0" i="0">
-                <a:solidFill>
-                  <a:srgbClr val="E0E0E0"/>
-                </a:solidFill>
-                <a:latin typeface="Lato"/>
-              </a:rPr>
-              <a:t>Go to **claude.ai/download** in your browser</a:t>
-            </a:r>
-          </a:p>
-          <a:p>
-            <a:pPr algn="l">
-              <a:spcAft>
-                <a:spcPts val="1200"/>
-              </a:spcAft>
-            </a:pPr>
-            <a:r>
-              <a:rPr sz="1800" b="1" i="0">
-                <a:solidFill>
-                  <a:srgbClr val="4A90D9"/>
-                </a:solidFill>
-                <a:latin typeface="Lato"/>
-              </a:rPr>
-              <a:t>2.  </a:t>
-            </a:r>
-            <a:r>
-              <a:rPr sz="1800" b="0" i="0">
-                <a:solidFill>
-                  <a:srgbClr val="E0E0E0"/>
-                </a:solidFill>
-                <a:latin typeface="Lato"/>
-              </a:rPr>
-              <a:t>Click **Download** for your operating system (Windows or Mac)</a:t>
-            </a:r>
-          </a:p>
-          <a:p>
-            <a:pPr algn="l">
-              <a:spcAft>
-                <a:spcPts val="1200"/>
-              </a:spcAft>
-            </a:pPr>
-            <a:r>
-              <a:rPr sz="1800" b="1" i="0">
-                <a:solidFill>
-                  <a:srgbClr val="4A90D9"/>
-                </a:solidFill>
-                <a:latin typeface="Lato"/>
-              </a:rPr>
-              <a:t>3.  </a:t>
-            </a:r>
-            <a:r>
-              <a:rPr sz="1800" b="0" i="0">
-                <a:solidFill>
-                  <a:srgbClr val="E0E0E0"/>
-                </a:solidFill>
-                <a:latin typeface="Lato"/>
-              </a:rPr>
-              <a:t>Open the downloaded file and install it (follow the prompts)</a:t>
-            </a:r>
-          </a:p>
-          <a:p>
-            <a:pPr algn="l">
-              <a:spcAft>
-                <a:spcPts val="1200"/>
-              </a:spcAft>
-            </a:pPr>
-            <a:r>
-              <a:rPr sz="1800" b="1" i="0">
-                <a:solidFill>
-                  <a:srgbClr val="4A90D9"/>
-                </a:solidFill>
-                <a:latin typeface="Lato"/>
-              </a:rPr>
-              <a:t>4.  </a:t>
-            </a:r>
-            <a:r>
-              <a:rPr sz="1800" b="0" i="0">
-                <a:solidFill>
-                  <a:srgbClr val="E0E0E0"/>
-                </a:solidFill>
-                <a:latin typeface="Lato"/>
-              </a:rPr>
-              <a:t>Open the Claude Desktop app</a:t>
-            </a:r>
-          </a:p>
-          <a:p>
-            <a:pPr algn="l">
-              <a:spcAft>
-                <a:spcPts val="1200"/>
-              </a:spcAft>
-            </a:pPr>
-            <a:r>
-              <a:rPr sz="1800" b="1" i="0">
-                <a:solidFill>
-                  <a:srgbClr val="4A90D9"/>
-                </a:solidFill>
-                <a:latin typeface="Lato"/>
-              </a:rPr>
-              <a:t>5.  </a:t>
-            </a:r>
-            <a:r>
-              <a:rPr sz="1800" b="0" i="0">
-                <a:solidFill>
-                  <a:srgbClr val="E0E0E0"/>
-                </a:solidFill>
-                <a:latin typeface="Lato"/>
-              </a:rPr>
-              <a:t>Sign in with your Claude account</a:t>
-            </a:r>
           </a:p>
         </p:txBody>
       </p:sp>
@@ -3657,8 +3684,8 @@
         </p:nvSpPr>
         <p:spPr>
           <a:xfrm>
-            <a:off x="914400" y="2560320"/>
-            <a:ext cx="10362895" cy="1371600"/>
+            <a:off x="731520" y="365760"/>
+            <a:ext cx="10728655" cy="914400"/>
           </a:xfrm>
           <a:prstGeom prst="rect">
             <a:avLst/>
@@ -3666,20 +3693,18 @@
           <a:noFill/>
         </p:spPr>
         <p:txBody>
-          <a:bodyPr wrap="square">
-            <a:spAutoFit/>
-          </a:bodyPr>
-          <a:lstStyle/>
-          <a:p>
-            <a:pPr algn="ctr"/>
-            <a:r>
-              <a:rPr sz="3200" b="1" i="0">
+          <a:bodyPr wrap="square"/>
+          <a:lstStyle/>
+          <a:p>
+            <a:pPr algn="l"/>
+            <a:r>
+              <a:rPr sz="2800" b="1" i="0">
                 <a:solidFill>
                   <a:srgbClr val="FFFFFF"/>
                 </a:solidFill>
                 <a:latin typeface="Lato"/>
               </a:rPr>
-              <a:t>Path C: Desktop App + Terminal (Recommended)</a:t>
+              <a:t>Launch It</a:t>
             </a:r>
           </a:p>
         </p:txBody>
@@ -3692,8 +3717,8 @@
         </p:nvSpPr>
         <p:spPr>
           <a:xfrm>
-            <a:off x="4724247" y="4114800"/>
-            <a:ext cx="2743200" cy="54864"/>
+            <a:off x="5181447" y="1325880"/>
+            <a:ext cx="1828800" cy="54864"/>
           </a:xfrm>
           <a:prstGeom prst="rect">
             <a:avLst/>
@@ -3724,6 +3749,95 @@
           <a:lstStyle/>
           <a:p>
             <a:pPr algn="ctr"/>
+          </a:p>
+        </p:txBody>
+      </p:sp>
+      <p:sp>
+        <p:nvSpPr>
+          <p:cNvPr id="4" name="TextBox 3"/>
+          <p:cNvSpPr txBox="1"/>
+          <p:nvPr/>
+        </p:nvSpPr>
+        <p:spPr>
+          <a:xfrm>
+            <a:off x="731520" y="1645920"/>
+            <a:ext cx="10728655" cy="4754880"/>
+          </a:xfrm>
+          <a:prstGeom prst="rect">
+            <a:avLst/>
+          </a:prstGeom>
+          <a:noFill/>
+        </p:spPr>
+        <p:txBody>
+          <a:bodyPr wrap="square"/>
+          <a:lstStyle/>
+          <a:p>
+            <a:pPr algn="l">
+              <a:spcAft>
+                <a:spcPts val="1000"/>
+              </a:spcAft>
+            </a:pPr>
+            <a:r>
+              <a:rPr sz="1800" b="0" i="0">
+                <a:solidFill>
+                  <a:srgbClr val="E0E0E0"/>
+                </a:solidFill>
+                <a:latin typeface="Lato"/>
+              </a:rPr>
+              <a:t>•  Open </a:t>
+            </a:r>
+            <a:r>
+              <a:rPr sz="1800" b="1" i="0">
+                <a:solidFill>
+                  <a:srgbClr val="4A90D9"/>
+                </a:solidFill>
+                <a:latin typeface="Lato"/>
+              </a:rPr>
+              <a:t>Warp</a:t>
+            </a:r>
+            <a:r>
+              <a:rPr sz="1800" b="0" i="0">
+                <a:solidFill>
+                  <a:srgbClr val="E0E0E0"/>
+                </a:solidFill>
+                <a:latin typeface="Lato"/>
+              </a:rPr>
+              <a:t>, type `claude`, press </a:t>
+            </a:r>
+            <a:r>
+              <a:rPr sz="1800" b="1" i="0">
+                <a:solidFill>
+                  <a:srgbClr val="4A90D9"/>
+                </a:solidFill>
+                <a:latin typeface="Lato"/>
+              </a:rPr>
+              <a:t>Enter</a:t>
+            </a:r>
+            <a:r>
+              <a:rPr sz="1800" b="0" i="0">
+                <a:solidFill>
+                  <a:srgbClr val="E0E0E0"/>
+                </a:solidFill>
+                <a:latin typeface="Lato"/>
+              </a:rPr>
+              <a:t> — you should see a welcome message</a:t>
+            </a:r>
+          </a:p>
+          <a:p>
+            <a:pPr algn="l">
+              <a:spcAft>
+                <a:spcPts val="1000"/>
+              </a:spcAft>
+            </a:pPr>
+            <a:r>
+              <a:rPr sz="1800" b="0" i="0">
+                <a:solidFill>
+                  <a:srgbClr val="E0E0E0"/>
+                </a:solidFill>
+                <a:latin typeface="Lato"/>
+              </a:rPr>
+              <a:t>•  If it asks you to sign in, follow the prompts — it opens your browser</a:t>
+            </a:r>
           </a:p>
         </p:txBody>
       </p:sp>
@@ -3761,8 +3875,8 @@
         </p:nvSpPr>
         <p:spPr>
           <a:xfrm>
-            <a:off x="731520" y="365760"/>
-            <a:ext cx="10728655" cy="914400"/>
+            <a:off x="914400" y="2560320"/>
+            <a:ext cx="10362895" cy="1371600"/>
           </a:xfrm>
           <a:prstGeom prst="rect">
             <a:avLst/>
@@ -3770,18 +3884,20 @@
           <a:noFill/>
         </p:spPr>
         <p:txBody>
-          <a:bodyPr wrap="square"/>
-          <a:lstStyle/>
-          <a:p>
-            <a:pPr algn="l"/>
-            <a:r>
-              <a:rPr sz="2800" b="1" i="0">
+          <a:bodyPr wrap="square">
+            <a:spAutoFit/>
+          </a:bodyPr>
+          <a:lstStyle/>
+          <a:p>
+            <a:pPr algn="ctr"/>
+            <a:r>
+              <a:rPr sz="3200" b="1" i="0">
                 <a:solidFill>
                   <a:srgbClr val="FFFFFF"/>
                 </a:solidFill>
                 <a:latin typeface="Lato"/>
               </a:rPr>
-              <a:t>Steps</a:t>
+              <a:t>Path 2: Have Claude Desktop, Need Terminal</a:t>
             </a:r>
           </a:p>
         </p:txBody>
@@ -3794,8 +3910,8 @@
         </p:nvSpPr>
         <p:spPr>
           <a:xfrm>
-            <a:off x="5181447" y="1325880"/>
-            <a:ext cx="1828800" cy="54864"/>
+            <a:off x="4724247" y="4114800"/>
+            <a:ext cx="2743200" cy="54864"/>
           </a:xfrm>
           <a:prstGeom prst="rect">
             <a:avLst/>
@@ -3826,152 +3942,6 @@
           <a:lstStyle/>
           <a:p>
             <a:pPr algn="ctr"/>
-          </a:p>
-        </p:txBody>
-      </p:sp>
-      <p:sp>
-        <p:nvSpPr>
-          <p:cNvPr id="4" name="TextBox 3"/>
-          <p:cNvSpPr txBox="1"/>
-          <p:nvPr/>
-        </p:nvSpPr>
-        <p:spPr>
-          <a:xfrm>
-            <a:off x="731520" y="1645920"/>
-            <a:ext cx="10728655" cy="4754880"/>
-          </a:xfrm>
-          <a:prstGeom prst="rect">
-            <a:avLst/>
-          </a:prstGeom>
-          <a:noFill/>
-        </p:spPr>
-        <p:txBody>
-          <a:bodyPr wrap="square"/>
-          <a:lstStyle/>
-          <a:p>
-            <a:pPr algn="l">
-              <a:spcAft>
-                <a:spcPts val="1200"/>
-              </a:spcAft>
-            </a:pPr>
-            <a:r>
-              <a:rPr sz="1800" b="1" i="0">
-                <a:solidFill>
-                  <a:srgbClr val="4A90D9"/>
-                </a:solidFill>
-                <a:latin typeface="Lato"/>
-              </a:rPr>
-              <a:t>1.  </a:t>
-            </a:r>
-            <a:r>
-              <a:rPr sz="1800" b="0" i="0">
-                <a:solidFill>
-                  <a:srgbClr val="E0E0E0"/>
-                </a:solidFill>
-                <a:latin typeface="Lato"/>
-              </a:rPr>
-              <a:t>Install the Claude Desktop App (follow Path A above — steps 1 through 5)</a:t>
-            </a:r>
-          </a:p>
-          <a:p>
-            <a:pPr algn="l">
-              <a:spcAft>
-                <a:spcPts val="1200"/>
-              </a:spcAft>
-            </a:pPr>
-            <a:r>
-              <a:rPr sz="1800" b="1" i="0">
-                <a:solidFill>
-                  <a:srgbClr val="4A90D9"/>
-                </a:solidFill>
-                <a:latin typeface="Lato"/>
-              </a:rPr>
-              <a:t>2.  </a:t>
-            </a:r>
-            <a:r>
-              <a:rPr sz="1800" b="0" i="0">
-                <a:solidFill>
-                  <a:srgbClr val="E0E0E0"/>
-                </a:solidFill>
-                <a:latin typeface="Lato"/>
-              </a:rPr>
-              <a:t>Open the Claude Desktop app</a:t>
-            </a:r>
-          </a:p>
-          <a:p>
-            <a:pPr algn="l">
-              <a:spcAft>
-                <a:spcPts val="1200"/>
-              </a:spcAft>
-            </a:pPr>
-            <a:r>
-              <a:rPr sz="1800" b="1" i="0">
-                <a:solidFill>
-                  <a:srgbClr val="4A90D9"/>
-                </a:solidFill>
-                <a:latin typeface="Lato"/>
-              </a:rPr>
-              <a:t>3.  </a:t>
-            </a:r>
-            <a:r>
-              <a:rPr sz="1800" b="0" i="0">
-                <a:solidFill>
-                  <a:srgbClr val="E0E0E0"/>
-                </a:solidFill>
-                <a:latin typeface="Lato"/>
-              </a:rPr>
-              <a:t>Look for the **Terminal** or **Code** tab in the app</a:t>
-            </a:r>
-          </a:p>
-          <a:p>
-            <a:pPr algn="l">
-              <a:spcAft>
-                <a:spcPts val="1200"/>
-              </a:spcAft>
-            </a:pPr>
-            <a:r>
-              <a:rPr sz="1800" b="1" i="0">
-                <a:solidFill>
-                  <a:srgbClr val="4A90D9"/>
-                </a:solidFill>
-                <a:latin typeface="Lato"/>
-              </a:rPr>
-              <a:t>4.  </a:t>
-            </a:r>
-            <a:r>
-              <a:rPr sz="1800" b="0" i="0">
-                <a:solidFill>
-                  <a:srgbClr val="E0E0E0"/>
-                </a:solidFill>
-                <a:latin typeface="Lato"/>
-              </a:rPr>
-              <a:t>Click it — it will install Claude Code on your terminal automatically</a:t>
-            </a:r>
-          </a:p>
-          <a:p>
-            <a:pPr algn="l">
-              <a:spcAft>
-                <a:spcPts val="1200"/>
-              </a:spcAft>
-            </a:pPr>
-            <a:r>
-              <a:rPr sz="1800" b="1" i="0">
-                <a:solidFill>
-                  <a:srgbClr val="4A90D9"/>
-                </a:solidFill>
-                <a:latin typeface="Lato"/>
-              </a:rPr>
-              <a:t>5.  </a:t>
-            </a:r>
-            <a:r>
-              <a:rPr sz="1800" b="0" i="0">
-                <a:solidFill>
-                  <a:srgbClr val="E0E0E0"/>
-                </a:solidFill>
-                <a:latin typeface="Lato"/>
-              </a:rPr>
-              <a:t>Follow any prompts it shows you</a:t>
-            </a:r>
           </a:p>
         </p:txBody>
       </p:sp>
@@ -4009,8 +3979,8 @@
         </p:nvSpPr>
         <p:spPr>
           <a:xfrm>
-            <a:off x="914400" y="2560320"/>
-            <a:ext cx="10362895" cy="1371600"/>
+            <a:off x="731520" y="365760"/>
+            <a:ext cx="10728655" cy="914400"/>
           </a:xfrm>
           <a:prstGeom prst="rect">
             <a:avLst/>
@@ -4018,40 +3988,40 @@
           <a:noFill/>
         </p:spPr>
         <p:txBody>
-          <a:bodyPr wrap="square">
-            <a:spAutoFit/>
-          </a:bodyPr>
-          <a:lstStyle/>
-          <a:p>
-            <a:pPr algn="ctr"/>
-            <a:r>
-              <a:rPr sz="3200" b="1" i="0">
+          <a:bodyPr wrap="square"/>
+          <a:lstStyle/>
+          <a:p>
+            <a:pPr algn="l"/>
+            <a:r>
+              <a:rPr sz="2800" b="1" i="0">
                 <a:solidFill>
                   <a:srgbClr val="FFFFFF"/>
                 </a:solidFill>
                 <a:latin typeface="Lato"/>
               </a:rPr>
-              <a:t>Path B: Terminal-First (10 Steps)</a:t>
-            </a:r>
-          </a:p>
-        </p:txBody>
-      </p:sp>
-      <p:sp>
-        <p:nvSpPr>
-          <p:cNvPr id="3" name="Rectangle 2"/>
+              <a:t>Copy This Prompt into the Claude Code Tab</a:t>
+            </a:r>
+          </a:p>
+        </p:txBody>
+      </p:sp>
+      <p:sp>
+        <p:nvSpPr>
+          <p:cNvPr id="3" name="Rounded Rectangle 2"/>
           <p:cNvSpPr/>
           <p:nvPr/>
         </p:nvSpPr>
         <p:spPr>
           <a:xfrm>
-            <a:off x="4724247" y="4114800"/>
-            <a:ext cx="2743200" cy="54864"/>
-          </a:xfrm>
-          <a:prstGeom prst="rect">
-            <a:avLst/>
+            <a:off x="640080" y="1463040"/>
+            <a:ext cx="10911535" cy="4937760"/>
+          </a:xfrm>
+          <a:prstGeom prst="roundRect">
+            <a:avLst>
+              <a:gd name="adj" fmla="val 2000"/>
+            </a:avLst>
           </a:prstGeom>
           <a:solidFill>
-            <a:srgbClr val="4A90D9"/>
+            <a:srgbClr val="16213E"/>
           </a:solidFill>
           <a:ln>
             <a:noFill/>
@@ -4076,6 +4046,43 @@
           <a:lstStyle/>
           <a:p>
             <a:pPr algn="ctr"/>
+          </a:p>
+        </p:txBody>
+      </p:sp>
+      <p:sp>
+        <p:nvSpPr>
+          <p:cNvPr id="4" name="TextBox 3"/>
+          <p:cNvSpPr txBox="1"/>
+          <p:nvPr/>
+        </p:nvSpPr>
+        <p:spPr>
+          <a:xfrm>
+            <a:off x="914400" y="1645920"/>
+            <a:ext cx="10545775" cy="4572000"/>
+          </a:xfrm>
+          <a:prstGeom prst="rect">
+            <a:avLst/>
+          </a:prstGeom>
+          <a:noFill/>
+        </p:spPr>
+        <p:txBody>
+          <a:bodyPr wrap="square"/>
+          <a:lstStyle/>
+          <a:p>
+            <a:pPr>
+              <a:spcAft>
+                <a:spcPts val="200"/>
+              </a:spcAft>
+            </a:pPr>
+            <a:r>
+              <a:rPr sz="1400" b="0" i="0">
+                <a:solidFill>
+                  <a:srgbClr val="E0E0E0"/>
+                </a:solidFill>
+                <a:latin typeface="Consolas"/>
+              </a:rPr>
+              <a:t>I need you to install Claude Code so I can use it in my terminal. Please detect my operating system, install everything that is needed (including Node.js if missing), and walk me through each step one at a time. After each step, wait for me to confirm before moving on.</a:t>
+            </a:r>
           </a:p>
         </p:txBody>
       </p:sp>
@@ -4133,7 +4140,7 @@
                 </a:solidFill>
                 <a:latin typeface="Lato"/>
               </a:rPr>
-              <a:t>Step B1: Download Warp</a:t>
+              <a:t>Copy This Prompt into the Claude Code Tab</a:t>
             </a:r>
           </a:p>
         </p:txBody>
@@ -4203,17 +4210,26 @@
           <a:p>
             <a:pPr algn="l">
               <a:spcAft>
-                <a:spcPts val="1200"/>
+                <a:spcPts val="1000"/>
               </a:spcAft>
             </a:pPr>
             <a:r>
+              <a:rPr sz="1800" b="0" i="0">
+                <a:solidFill>
+                  <a:srgbClr val="E0E0E0"/>
+                </a:solidFill>
+                <a:latin typeface="Lato"/>
+              </a:rPr>
+              <a:t>•  In </a:t>
+            </a:r>
+            <a:r>
               <a:rPr sz="1800" b="1" i="0">
                 <a:solidFill>
                   <a:srgbClr val="4A90D9"/>
                 </a:solidFill>
                 <a:latin typeface="Lato"/>
               </a:rPr>
-              <a:t>1.  </a:t>
+              <a:t>Claude Desktop</a:t>
             </a:r>
             <a:r>
               <a:rPr sz="1800" b="0" i="0">
@@ -4222,48 +4238,66 @@
                 </a:solidFill>
                 <a:latin typeface="Lato"/>
               </a:rPr>
-              <a:t>Go to **warp.dev** in your browser</a:t>
+              <a:t>, click the </a:t>
+            </a:r>
+            <a:r>
+              <a:rPr sz="1800" b="1" i="0">
+                <a:solidFill>
+                  <a:srgbClr val="4A90D9"/>
+                </a:solidFill>
+                <a:latin typeface="Lato"/>
+              </a:rPr>
+              <a:t>Claude Code</a:t>
+            </a:r>
+            <a:r>
+              <a:rPr sz="1800" b="0" i="0">
+                <a:solidFill>
+                  <a:srgbClr val="E0E0E0"/>
+                </a:solidFill>
+                <a:latin typeface="Lato"/>
+              </a:rPr>
+              <a:t> tab (not the regular chat tab) and paste the prompt above</a:t>
             </a:r>
           </a:p>
           <a:p>
             <a:pPr algn="l">
               <a:spcAft>
-                <a:spcPts val="1200"/>
+                <a:spcPts val="1000"/>
               </a:spcAft>
             </a:pPr>
             <a:r>
-              <a:rPr sz="1800" b="1" i="0">
-                <a:solidFill>
-                  <a:srgbClr val="4A90D9"/>
-                </a:solidFill>
-                <a:latin typeface="Lato"/>
-              </a:rPr>
-              <a:t>2.  </a:t>
-            </a:r>
-            <a:r>
               <a:rPr sz="1800" b="0" i="0">
                 <a:solidFill>
                   <a:srgbClr val="E0E0E0"/>
                 </a:solidFill>
                 <a:latin typeface="Lato"/>
               </a:rPr>
-              <a:t>Click **Download**</a:t>
+              <a:t>•  Follow each step Claude gives you — if anything fails, paste the error back and ask Claude to help</a:t>
             </a:r>
           </a:p>
           <a:p>
             <a:pPr algn="l">
               <a:spcAft>
-                <a:spcPts val="1200"/>
+                <a:spcPts val="1000"/>
               </a:spcAft>
             </a:pPr>
             <a:r>
+              <a:rPr sz="1800" b="0" i="0">
+                <a:solidFill>
+                  <a:srgbClr val="E0E0E0"/>
+                </a:solidFill>
+                <a:latin typeface="Lato"/>
+              </a:rPr>
+              <a:t>•  When done: open </a:t>
+            </a:r>
+            <a:r>
               <a:rPr sz="1800" b="1" i="0">
                 <a:solidFill>
                   <a:srgbClr val="4A90D9"/>
                 </a:solidFill>
                 <a:latin typeface="Lato"/>
               </a:rPr>
-              <a:t>3.  </a:t>
+              <a:t>Warp</a:t>
             </a:r>
             <a:r>
               <a:rPr sz="1800" b="0" i="0">
@@ -4272,7 +4306,25 @@
                 </a:solidFill>
                 <a:latin typeface="Lato"/>
               </a:rPr>
-              <a:t>Open the downloaded file and install it</a:t>
+              <a:t>, type `claude`, press </a:t>
+            </a:r>
+            <a:r>
+              <a:rPr sz="1800" b="1" i="0">
+                <a:solidFill>
+                  <a:srgbClr val="4A90D9"/>
+                </a:solidFill>
+                <a:latin typeface="Lato"/>
+              </a:rPr>
+              <a:t>Enter</a:t>
+            </a:r>
+            <a:r>
+              <a:rPr sz="1800" b="0" i="0">
+                <a:solidFill>
+                  <a:srgbClr val="E0E0E0"/>
+                </a:solidFill>
+                <a:latin typeface="Lato"/>
+              </a:rPr>
+              <a:t> — you should see a welcome message</a:t>
             </a:r>
           </a:p>
         </p:txBody>
@@ -4333,7 +4385,7 @@
                 </a:solidFill>
                 <a:latin typeface="Lato"/>
               </a:rPr>
-              <a:t>Step B2: Open Warp</a:t>
+              <a:t>Path 3: Starting from Scratch</a:t>
             </a:r>
           </a:p>
         </p:txBody>
@@ -4435,7 +4487,7 @@
                 </a:solidFill>
                 <a:latin typeface="Lato"/>
               </a:rPr>
-              <a:t>Step B3: Windows Users Only — Switch to Git Bash</a:t>
+              <a:t>Install Claude Desktop, Then Follow Path 2</a:t>
             </a:r>
           </a:p>
         </p:txBody>
@@ -4524,7 +4576,7 @@
                 </a:solidFill>
                 <a:latin typeface="Lato"/>
               </a:rPr>
-              <a:t>Look at the top of Warp — next to the **+** tab button, there's a small dropdown</a:t>
+              <a:t>Go to **claude.ai/download** and click **Download** for your OS</a:t>
             </a:r>
           </a:p>
           <a:p>
@@ -4549,7 +4601,7 @@
                 </a:solidFill>
                 <a:latin typeface="Lato"/>
               </a:rPr>
-              <a:t>Click it and select **Git Bash**</a:t>
+              <a:t>Install it, open the app, and sign in with your Claude Pro or Max account</a:t>
             </a:r>
           </a:p>
           <a:p>
@@ -4574,7 +4626,7 @@
                 </a:solidFill>
                 <a:latin typeface="Lato"/>
               </a:rPr>
-              <a:t>To make this permanent: go to **Settings → Features → Session** and set **Startup shell** to Git Bash</a:t>
+              <a:t>Now scroll back up and follow **Path 2** above</a:t>
             </a:r>
           </a:p>
         </p:txBody>
@@ -4635,7 +4687,7 @@
                 </a:solidFill>
                 <a:latin typeface="Lato"/>
               </a:rPr>
-              <a:t>Step B4: Watch the Install Video (Optional)</a:t>
+              <a:t>Troubleshooting</a:t>
             </a:r>
           </a:p>
         </p:txBody>
@@ -4737,1370 +4789,6 @@
                 </a:solidFill>
                 <a:latin typeface="Lato"/>
               </a:rPr>
-              <a:t>Step B5: Check If Node.js Is Installed</a:t>
-            </a:r>
-          </a:p>
-        </p:txBody>
-      </p:sp>
-      <p:sp>
-        <p:nvSpPr>
-          <p:cNvPr id="3" name="Rounded Rectangle 2"/>
-          <p:cNvSpPr/>
-          <p:nvPr/>
-        </p:nvSpPr>
-        <p:spPr>
-          <a:xfrm>
-            <a:off x="640080" y="1463040"/>
-            <a:ext cx="10911535" cy="4937760"/>
-          </a:xfrm>
-          <a:prstGeom prst="roundRect">
-            <a:avLst>
-              <a:gd name="adj" fmla="val 2000"/>
-            </a:avLst>
-          </a:prstGeom>
-          <a:solidFill>
-            <a:srgbClr val="16213E"/>
-          </a:solidFill>
-          <a:ln>
-            <a:noFill/>
-          </a:ln>
-        </p:spPr>
-        <p:style>
-          <a:lnRef idx="1">
-            <a:schemeClr val="accent1"/>
-          </a:lnRef>
-          <a:fillRef idx="3">
-            <a:schemeClr val="accent1"/>
-          </a:fillRef>
-          <a:effectRef idx="2">
-            <a:schemeClr val="accent1"/>
-          </a:effectRef>
-          <a:fontRef idx="minor">
-            <a:schemeClr val="lt1"/>
-          </a:fontRef>
-        </p:style>
-        <p:txBody>
-          <a:bodyPr rtlCol="0" anchor="ctr"/>
-          <a:lstStyle/>
-          <a:p>
-            <a:pPr algn="ctr"/>
-          </a:p>
-        </p:txBody>
-      </p:sp>
-      <p:sp>
-        <p:nvSpPr>
-          <p:cNvPr id="4" name="TextBox 3"/>
-          <p:cNvSpPr txBox="1"/>
-          <p:nvPr/>
-        </p:nvSpPr>
-        <p:spPr>
-          <a:xfrm>
-            <a:off x="914400" y="1645920"/>
-            <a:ext cx="10545775" cy="4572000"/>
-          </a:xfrm>
-          <a:prstGeom prst="rect">
-            <a:avLst/>
-          </a:prstGeom>
-          <a:noFill/>
-        </p:spPr>
-        <p:txBody>
-          <a:bodyPr wrap="square"/>
-          <a:lstStyle/>
-          <a:p>
-            <a:pPr>
-              <a:spcAft>
-                <a:spcPts val="200"/>
-              </a:spcAft>
-            </a:pPr>
-            <a:r>
-              <a:rPr sz="1400" b="0" i="0">
-                <a:solidFill>
-                  <a:srgbClr val="E0E0E0"/>
-                </a:solidFill>
-                <a:latin typeface="Consolas"/>
-              </a:rPr>
-              <a:t>node --version</a:t>
-            </a:r>
-          </a:p>
-        </p:txBody>
-      </p:sp>
-    </p:spTree>
-  </p:cSld>
-  <p:clrMapOvr>
-    <a:masterClrMapping/>
-  </p:clrMapOvr>
-</p:sld>
-</file>
-
-<file path=ppt/slides/slide2.xml><?xml version="1.0" encoding="utf-8"?>
-<p:sld xmlns:a="http://schemas.openxmlformats.org/drawingml/2006/main" xmlns:p="http://schemas.openxmlformats.org/presentationml/2006/main" xmlns:r="http://schemas.openxmlformats.org/officeDocument/2006/relationships">
-  <p:cSld>
-    <p:bg>
-      <p:bgPr>
-        <a:solidFill>
-          <a:srgbClr val="1A1A2E"/>
-        </a:solidFill>
-        <a:effectLst/>
-      </p:bgPr>
-    </p:bg>
-    <p:spTree>
-      <p:nvGrpSpPr>
-        <p:cNvPr id="1" name=""/>
-        <p:cNvGrpSpPr/>
-        <p:nvPr/>
-      </p:nvGrpSpPr>
-      <p:grpSpPr/>
-      <p:sp>
-        <p:nvSpPr>
-          <p:cNvPr id="2" name="TextBox 1"/>
-          <p:cNvSpPr txBox="1"/>
-          <p:nvPr/>
-        </p:nvSpPr>
-        <p:spPr>
-          <a:xfrm>
-            <a:off x="914400" y="2560320"/>
-            <a:ext cx="10362895" cy="1371600"/>
-          </a:xfrm>
-          <a:prstGeom prst="rect">
-            <a:avLst/>
-          </a:prstGeom>
-          <a:noFill/>
-        </p:spPr>
-        <p:txBody>
-          <a:bodyPr wrap="square">
-            <a:spAutoFit/>
-          </a:bodyPr>
-          <a:lstStyle/>
-          <a:p>
-            <a:pPr algn="ctr"/>
-            <a:r>
-              <a:rPr sz="3200" b="1" i="0">
-                <a:solidFill>
-                  <a:srgbClr val="FFFFFF"/>
-                </a:solidFill>
-                <a:latin typeface="Lato"/>
-              </a:rPr>
-              <a:t>What You Need Before Starting</a:t>
-            </a:r>
-          </a:p>
-        </p:txBody>
-      </p:sp>
-      <p:sp>
-        <p:nvSpPr>
-          <p:cNvPr id="3" name="Rectangle 2"/>
-          <p:cNvSpPr/>
-          <p:nvPr/>
-        </p:nvSpPr>
-        <p:spPr>
-          <a:xfrm>
-            <a:off x="4724247" y="4114800"/>
-            <a:ext cx="2743200" cy="54864"/>
-          </a:xfrm>
-          <a:prstGeom prst="rect">
-            <a:avLst/>
-          </a:prstGeom>
-          <a:solidFill>
-            <a:srgbClr val="4A90D9"/>
-          </a:solidFill>
-          <a:ln>
-            <a:noFill/>
-          </a:ln>
-        </p:spPr>
-        <p:style>
-          <a:lnRef idx="1">
-            <a:schemeClr val="accent1"/>
-          </a:lnRef>
-          <a:fillRef idx="3">
-            <a:schemeClr val="accent1"/>
-          </a:fillRef>
-          <a:effectRef idx="2">
-            <a:schemeClr val="accent1"/>
-          </a:effectRef>
-          <a:fontRef idx="minor">
-            <a:schemeClr val="lt1"/>
-          </a:fontRef>
-        </p:style>
-        <p:txBody>
-          <a:bodyPr rtlCol="0" anchor="ctr"/>
-          <a:lstStyle/>
-          <a:p>
-            <a:pPr algn="ctr"/>
-          </a:p>
-        </p:txBody>
-      </p:sp>
-    </p:spTree>
-  </p:cSld>
-  <p:clrMapOvr>
-    <a:masterClrMapping/>
-  </p:clrMapOvr>
-</p:sld>
-</file>
-
-<file path=ppt/slides/slide20.xml><?xml version="1.0" encoding="utf-8"?>
-<p:sld xmlns:a="http://schemas.openxmlformats.org/drawingml/2006/main" xmlns:p="http://schemas.openxmlformats.org/presentationml/2006/main" xmlns:r="http://schemas.openxmlformats.org/officeDocument/2006/relationships">
-  <p:cSld>
-    <p:bg>
-      <p:bgPr>
-        <a:solidFill>
-          <a:srgbClr val="1A1A2E"/>
-        </a:solidFill>
-        <a:effectLst/>
-      </p:bgPr>
-    </p:bg>
-    <p:spTree>
-      <p:nvGrpSpPr>
-        <p:cNvPr id="1" name=""/>
-        <p:cNvGrpSpPr/>
-        <p:nvPr/>
-      </p:nvGrpSpPr>
-      <p:grpSpPr/>
-      <p:sp>
-        <p:nvSpPr>
-          <p:cNvPr id="2" name="TextBox 1"/>
-          <p:cNvSpPr txBox="1"/>
-          <p:nvPr/>
-        </p:nvSpPr>
-        <p:spPr>
-          <a:xfrm>
-            <a:off x="914400" y="2560320"/>
-            <a:ext cx="10362895" cy="1371600"/>
-          </a:xfrm>
-          <a:prstGeom prst="rect">
-            <a:avLst/>
-          </a:prstGeom>
-          <a:noFill/>
-        </p:spPr>
-        <p:txBody>
-          <a:bodyPr wrap="square">
-            <a:spAutoFit/>
-          </a:bodyPr>
-          <a:lstStyle/>
-          <a:p>
-            <a:pPr algn="ctr"/>
-            <a:r>
-              <a:rPr sz="3200" b="1" i="0">
-                <a:solidFill>
-                  <a:srgbClr val="FFFFFF"/>
-                </a:solidFill>
-                <a:latin typeface="Lato"/>
-              </a:rPr>
-              <a:t>Step B5: Check If Node.js Is Installed</a:t>
-            </a:r>
-          </a:p>
-        </p:txBody>
-      </p:sp>
-      <p:sp>
-        <p:nvSpPr>
-          <p:cNvPr id="3" name="Rectangle 2"/>
-          <p:cNvSpPr/>
-          <p:nvPr/>
-        </p:nvSpPr>
-        <p:spPr>
-          <a:xfrm>
-            <a:off x="4724247" y="4114800"/>
-            <a:ext cx="2743200" cy="54864"/>
-          </a:xfrm>
-          <a:prstGeom prst="rect">
-            <a:avLst/>
-          </a:prstGeom>
-          <a:solidFill>
-            <a:srgbClr val="4A90D9"/>
-          </a:solidFill>
-          <a:ln>
-            <a:noFill/>
-          </a:ln>
-        </p:spPr>
-        <p:style>
-          <a:lnRef idx="1">
-            <a:schemeClr val="accent1"/>
-          </a:lnRef>
-          <a:fillRef idx="3">
-            <a:schemeClr val="accent1"/>
-          </a:fillRef>
-          <a:effectRef idx="2">
-            <a:schemeClr val="accent1"/>
-          </a:effectRef>
-          <a:fontRef idx="minor">
-            <a:schemeClr val="lt1"/>
-          </a:fontRef>
-        </p:style>
-        <p:txBody>
-          <a:bodyPr rtlCol="0" anchor="ctr"/>
-          <a:lstStyle/>
-          <a:p>
-            <a:pPr algn="ctr"/>
-          </a:p>
-        </p:txBody>
-      </p:sp>
-    </p:spTree>
-  </p:cSld>
-  <p:clrMapOvr>
-    <a:masterClrMapping/>
-  </p:clrMapOvr>
-</p:sld>
-</file>
-
-<file path=ppt/slides/slide21.xml><?xml version="1.0" encoding="utf-8"?>
-<p:sld xmlns:a="http://schemas.openxmlformats.org/drawingml/2006/main" xmlns:p="http://schemas.openxmlformats.org/presentationml/2006/main" xmlns:r="http://schemas.openxmlformats.org/officeDocument/2006/relationships">
-  <p:cSld>
-    <p:bg>
-      <p:bgPr>
-        <a:solidFill>
-          <a:srgbClr val="1A1A2E"/>
-        </a:solidFill>
-        <a:effectLst/>
-      </p:bgPr>
-    </p:bg>
-    <p:spTree>
-      <p:nvGrpSpPr>
-        <p:cNvPr id="1" name=""/>
-        <p:cNvGrpSpPr/>
-        <p:nvPr/>
-      </p:nvGrpSpPr>
-      <p:grpSpPr/>
-      <p:sp>
-        <p:nvSpPr>
-          <p:cNvPr id="2" name="TextBox 1"/>
-          <p:cNvSpPr txBox="1"/>
-          <p:nvPr/>
-        </p:nvSpPr>
-        <p:spPr>
-          <a:xfrm>
-            <a:off x="731520" y="365760"/>
-            <a:ext cx="10728655" cy="914400"/>
-          </a:xfrm>
-          <a:prstGeom prst="rect">
-            <a:avLst/>
-          </a:prstGeom>
-          <a:noFill/>
-        </p:spPr>
-        <p:txBody>
-          <a:bodyPr wrap="square"/>
-          <a:lstStyle/>
-          <a:p>
-            <a:pPr algn="l"/>
-            <a:r>
-              <a:rPr sz="2800" b="1" i="0">
-                <a:solidFill>
-                  <a:srgbClr val="FFFFFF"/>
-                </a:solidFill>
-                <a:latin typeface="Lato"/>
-              </a:rPr>
-              <a:t>Step B6: Install Node.js</a:t>
-            </a:r>
-          </a:p>
-        </p:txBody>
-      </p:sp>
-      <p:sp>
-        <p:nvSpPr>
-          <p:cNvPr id="3" name="Rectangle 2"/>
-          <p:cNvSpPr/>
-          <p:nvPr/>
-        </p:nvSpPr>
-        <p:spPr>
-          <a:xfrm>
-            <a:off x="5181447" y="1325880"/>
-            <a:ext cx="1828800" cy="54864"/>
-          </a:xfrm>
-          <a:prstGeom prst="rect">
-            <a:avLst/>
-          </a:prstGeom>
-          <a:solidFill>
-            <a:srgbClr val="4A90D9"/>
-          </a:solidFill>
-          <a:ln>
-            <a:noFill/>
-          </a:ln>
-        </p:spPr>
-        <p:style>
-          <a:lnRef idx="1">
-            <a:schemeClr val="accent1"/>
-          </a:lnRef>
-          <a:fillRef idx="3">
-            <a:schemeClr val="accent1"/>
-          </a:fillRef>
-          <a:effectRef idx="2">
-            <a:schemeClr val="accent1"/>
-          </a:effectRef>
-          <a:fontRef idx="minor">
-            <a:schemeClr val="lt1"/>
-          </a:fontRef>
-        </p:style>
-        <p:txBody>
-          <a:bodyPr rtlCol="0" anchor="ctr"/>
-          <a:lstStyle/>
-          <a:p>
-            <a:pPr algn="ctr"/>
-          </a:p>
-        </p:txBody>
-      </p:sp>
-      <p:sp>
-        <p:nvSpPr>
-          <p:cNvPr id="4" name="TextBox 3"/>
-          <p:cNvSpPr txBox="1"/>
-          <p:nvPr/>
-        </p:nvSpPr>
-        <p:spPr>
-          <a:xfrm>
-            <a:off x="731520" y="1645920"/>
-            <a:ext cx="10728655" cy="4754880"/>
-          </a:xfrm>
-          <a:prstGeom prst="rect">
-            <a:avLst/>
-          </a:prstGeom>
-          <a:noFill/>
-        </p:spPr>
-        <p:txBody>
-          <a:bodyPr wrap="square"/>
-          <a:lstStyle/>
-          <a:p>
-            <a:pPr algn="l">
-              <a:spcAft>
-                <a:spcPts val="1200"/>
-              </a:spcAft>
-            </a:pPr>
-            <a:r>
-              <a:rPr sz="1800" b="1" i="0">
-                <a:solidFill>
-                  <a:srgbClr val="4A90D9"/>
-                </a:solidFill>
-                <a:latin typeface="Lato"/>
-              </a:rPr>
-              <a:t>1.  </a:t>
-            </a:r>
-            <a:r>
-              <a:rPr sz="1800" b="0" i="0">
-                <a:solidFill>
-                  <a:srgbClr val="E0E0E0"/>
-                </a:solidFill>
-                <a:latin typeface="Lato"/>
-              </a:rPr>
-              <a:t>Go to **nodejs.org** in your browser</a:t>
-            </a:r>
-          </a:p>
-          <a:p>
-            <a:pPr algn="l">
-              <a:spcAft>
-                <a:spcPts val="1200"/>
-              </a:spcAft>
-            </a:pPr>
-            <a:r>
-              <a:rPr sz="1800" b="1" i="0">
-                <a:solidFill>
-                  <a:srgbClr val="4A90D9"/>
-                </a:solidFill>
-                <a:latin typeface="Lato"/>
-              </a:rPr>
-              <a:t>2.  </a:t>
-            </a:r>
-            <a:r>
-              <a:rPr sz="1800" b="0" i="0">
-                <a:solidFill>
-                  <a:srgbClr val="E0E0E0"/>
-                </a:solidFill>
-                <a:latin typeface="Lato"/>
-              </a:rPr>
-              <a:t>Download the **LTS** version (the big green button)</a:t>
-            </a:r>
-          </a:p>
-          <a:p>
-            <a:pPr algn="l">
-              <a:spcAft>
-                <a:spcPts val="1200"/>
-              </a:spcAft>
-            </a:pPr>
-            <a:r>
-              <a:rPr sz="1800" b="1" i="0">
-                <a:solidFill>
-                  <a:srgbClr val="4A90D9"/>
-                </a:solidFill>
-                <a:latin typeface="Lato"/>
-              </a:rPr>
-              <a:t>3.  </a:t>
-            </a:r>
-            <a:r>
-              <a:rPr sz="1800" b="0" i="0">
-                <a:solidFill>
-                  <a:srgbClr val="E0E0E0"/>
-                </a:solidFill>
-                <a:latin typeface="Lato"/>
-              </a:rPr>
-              <a:t>Open the downloaded file and install it (click Next through everything)</a:t>
-            </a:r>
-          </a:p>
-          <a:p>
-            <a:pPr algn="l">
-              <a:spcAft>
-                <a:spcPts val="1200"/>
-              </a:spcAft>
-            </a:pPr>
-            <a:r>
-              <a:rPr sz="1800" b="1" i="0">
-                <a:solidFill>
-                  <a:srgbClr val="4A90D9"/>
-                </a:solidFill>
-                <a:latin typeface="Lato"/>
-              </a:rPr>
-              <a:t>4.  </a:t>
-            </a:r>
-            <a:r>
-              <a:rPr sz="1800" b="0" i="0">
-                <a:solidFill>
-                  <a:srgbClr val="E0E0E0"/>
-                </a:solidFill>
-                <a:latin typeface="Lato"/>
-              </a:rPr>
-              <a:t>**Close Warp completely and reopen it**</a:t>
-            </a:r>
-          </a:p>
-          <a:p>
-            <a:pPr algn="l">
-              <a:spcAft>
-                <a:spcPts val="1200"/>
-              </a:spcAft>
-            </a:pPr>
-            <a:r>
-              <a:rPr sz="1800" b="1" i="0">
-                <a:solidFill>
-                  <a:srgbClr val="4A90D9"/>
-                </a:solidFill>
-                <a:latin typeface="Lato"/>
-              </a:rPr>
-              <a:t>5.  </a:t>
-            </a:r>
-            <a:r>
-              <a:rPr sz="1800" b="0" i="0">
-                <a:solidFill>
-                  <a:srgbClr val="E0E0E0"/>
-                </a:solidFill>
-                <a:latin typeface="Lato"/>
-              </a:rPr>
-              <a:t>Try `node --version` again — you should see a version number now</a:t>
-            </a:r>
-          </a:p>
-        </p:txBody>
-      </p:sp>
-    </p:spTree>
-  </p:cSld>
-  <p:clrMapOvr>
-    <a:masterClrMapping/>
-  </p:clrMapOvr>
-</p:sld>
-</file>
-
-<file path=ppt/slides/slide22.xml><?xml version="1.0" encoding="utf-8"?>
-<p:sld xmlns:a="http://schemas.openxmlformats.org/drawingml/2006/main" xmlns:p="http://schemas.openxmlformats.org/presentationml/2006/main" xmlns:r="http://schemas.openxmlformats.org/officeDocument/2006/relationships">
-  <p:cSld>
-    <p:bg>
-      <p:bgPr>
-        <a:solidFill>
-          <a:srgbClr val="1A1A2E"/>
-        </a:solidFill>
-        <a:effectLst/>
-      </p:bgPr>
-    </p:bg>
-    <p:spTree>
-      <p:nvGrpSpPr>
-        <p:cNvPr id="1" name=""/>
-        <p:cNvGrpSpPr/>
-        <p:nvPr/>
-      </p:nvGrpSpPr>
-      <p:grpSpPr/>
-      <p:sp>
-        <p:nvSpPr>
-          <p:cNvPr id="2" name="TextBox 1"/>
-          <p:cNvSpPr txBox="1"/>
-          <p:nvPr/>
-        </p:nvSpPr>
-        <p:spPr>
-          <a:xfrm>
-            <a:off x="731520" y="365760"/>
-            <a:ext cx="10728655" cy="914400"/>
-          </a:xfrm>
-          <a:prstGeom prst="rect">
-            <a:avLst/>
-          </a:prstGeom>
-          <a:noFill/>
-        </p:spPr>
-        <p:txBody>
-          <a:bodyPr wrap="square"/>
-          <a:lstStyle/>
-          <a:p>
-            <a:pPr algn="l"/>
-            <a:r>
-              <a:rPr sz="2800" b="1" i="0">
-                <a:solidFill>
-                  <a:srgbClr val="FFFFFF"/>
-                </a:solidFill>
-                <a:latin typeface="Lato"/>
-              </a:rPr>
-              <a:t>Step B7: Install Claude Code</a:t>
-            </a:r>
-          </a:p>
-        </p:txBody>
-      </p:sp>
-      <p:sp>
-        <p:nvSpPr>
-          <p:cNvPr id="3" name="Rounded Rectangle 2"/>
-          <p:cNvSpPr/>
-          <p:nvPr/>
-        </p:nvSpPr>
-        <p:spPr>
-          <a:xfrm>
-            <a:off x="640080" y="1463040"/>
-            <a:ext cx="10911535" cy="4937760"/>
-          </a:xfrm>
-          <a:prstGeom prst="roundRect">
-            <a:avLst>
-              <a:gd name="adj" fmla="val 2000"/>
-            </a:avLst>
-          </a:prstGeom>
-          <a:solidFill>
-            <a:srgbClr val="16213E"/>
-          </a:solidFill>
-          <a:ln>
-            <a:noFill/>
-          </a:ln>
-        </p:spPr>
-        <p:style>
-          <a:lnRef idx="1">
-            <a:schemeClr val="accent1"/>
-          </a:lnRef>
-          <a:fillRef idx="3">
-            <a:schemeClr val="accent1"/>
-          </a:fillRef>
-          <a:effectRef idx="2">
-            <a:schemeClr val="accent1"/>
-          </a:effectRef>
-          <a:fontRef idx="minor">
-            <a:schemeClr val="lt1"/>
-          </a:fontRef>
-        </p:style>
-        <p:txBody>
-          <a:bodyPr rtlCol="0" anchor="ctr"/>
-          <a:lstStyle/>
-          <a:p>
-            <a:pPr algn="ctr"/>
-          </a:p>
-        </p:txBody>
-      </p:sp>
-      <p:sp>
-        <p:nvSpPr>
-          <p:cNvPr id="4" name="TextBox 3"/>
-          <p:cNvSpPr txBox="1"/>
-          <p:nvPr/>
-        </p:nvSpPr>
-        <p:spPr>
-          <a:xfrm>
-            <a:off x="914400" y="1645920"/>
-            <a:ext cx="10545775" cy="4572000"/>
-          </a:xfrm>
-          <a:prstGeom prst="rect">
-            <a:avLst/>
-          </a:prstGeom>
-          <a:noFill/>
-        </p:spPr>
-        <p:txBody>
-          <a:bodyPr wrap="square"/>
-          <a:lstStyle/>
-          <a:p>
-            <a:pPr>
-              <a:spcAft>
-                <a:spcPts val="200"/>
-              </a:spcAft>
-            </a:pPr>
-            <a:r>
-              <a:rPr sz="1400" b="0" i="0">
-                <a:solidFill>
-                  <a:srgbClr val="E0E0E0"/>
-                </a:solidFill>
-                <a:latin typeface="Consolas"/>
-              </a:rPr>
-              <a:t>npm install -g @anthropic-ai/claude-code</a:t>
-            </a:r>
-          </a:p>
-        </p:txBody>
-      </p:sp>
-    </p:spTree>
-  </p:cSld>
-  <p:clrMapOvr>
-    <a:masterClrMapping/>
-  </p:clrMapOvr>
-</p:sld>
-</file>
-
-<file path=ppt/slides/slide23.xml><?xml version="1.0" encoding="utf-8"?>
-<p:sld xmlns:a="http://schemas.openxmlformats.org/drawingml/2006/main" xmlns:p="http://schemas.openxmlformats.org/presentationml/2006/main" xmlns:r="http://schemas.openxmlformats.org/officeDocument/2006/relationships">
-  <p:cSld>
-    <p:bg>
-      <p:bgPr>
-        <a:solidFill>
-          <a:srgbClr val="1A1A2E"/>
-        </a:solidFill>
-        <a:effectLst/>
-      </p:bgPr>
-    </p:bg>
-    <p:spTree>
-      <p:nvGrpSpPr>
-        <p:cNvPr id="1" name=""/>
-        <p:cNvGrpSpPr/>
-        <p:nvPr/>
-      </p:nvGrpSpPr>
-      <p:grpSpPr/>
-      <p:sp>
-        <p:nvSpPr>
-          <p:cNvPr id="2" name="TextBox 1"/>
-          <p:cNvSpPr txBox="1"/>
-          <p:nvPr/>
-        </p:nvSpPr>
-        <p:spPr>
-          <a:xfrm>
-            <a:off x="914400" y="2560320"/>
-            <a:ext cx="10362895" cy="1371600"/>
-          </a:xfrm>
-          <a:prstGeom prst="rect">
-            <a:avLst/>
-          </a:prstGeom>
-          <a:noFill/>
-        </p:spPr>
-        <p:txBody>
-          <a:bodyPr wrap="square">
-            <a:spAutoFit/>
-          </a:bodyPr>
-          <a:lstStyle/>
-          <a:p>
-            <a:pPr algn="ctr"/>
-            <a:r>
-              <a:rPr sz="3200" b="1" i="0">
-                <a:solidFill>
-                  <a:srgbClr val="FFFFFF"/>
-                </a:solidFill>
-                <a:latin typeface="Lato"/>
-              </a:rPr>
-              <a:t>Step B7: Install Claude Code</a:t>
-            </a:r>
-          </a:p>
-        </p:txBody>
-      </p:sp>
-      <p:sp>
-        <p:nvSpPr>
-          <p:cNvPr id="3" name="Rectangle 2"/>
-          <p:cNvSpPr/>
-          <p:nvPr/>
-        </p:nvSpPr>
-        <p:spPr>
-          <a:xfrm>
-            <a:off x="4724247" y="4114800"/>
-            <a:ext cx="2743200" cy="54864"/>
-          </a:xfrm>
-          <a:prstGeom prst="rect">
-            <a:avLst/>
-          </a:prstGeom>
-          <a:solidFill>
-            <a:srgbClr val="4A90D9"/>
-          </a:solidFill>
-          <a:ln>
-            <a:noFill/>
-          </a:ln>
-        </p:spPr>
-        <p:style>
-          <a:lnRef idx="1">
-            <a:schemeClr val="accent1"/>
-          </a:lnRef>
-          <a:fillRef idx="3">
-            <a:schemeClr val="accent1"/>
-          </a:fillRef>
-          <a:effectRef idx="2">
-            <a:schemeClr val="accent1"/>
-          </a:effectRef>
-          <a:fontRef idx="minor">
-            <a:schemeClr val="lt1"/>
-          </a:fontRef>
-        </p:style>
-        <p:txBody>
-          <a:bodyPr rtlCol="0" anchor="ctr"/>
-          <a:lstStyle/>
-          <a:p>
-            <a:pPr algn="ctr"/>
-          </a:p>
-        </p:txBody>
-      </p:sp>
-    </p:spTree>
-  </p:cSld>
-  <p:clrMapOvr>
-    <a:masterClrMapping/>
-  </p:clrMapOvr>
-</p:sld>
-</file>
-
-<file path=ppt/slides/slide24.xml><?xml version="1.0" encoding="utf-8"?>
-<p:sld xmlns:a="http://schemas.openxmlformats.org/drawingml/2006/main" xmlns:p="http://schemas.openxmlformats.org/presentationml/2006/main" xmlns:r="http://schemas.openxmlformats.org/officeDocument/2006/relationships">
-  <p:cSld>
-    <p:bg>
-      <p:bgPr>
-        <a:solidFill>
-          <a:srgbClr val="1A1A2E"/>
-        </a:solidFill>
-        <a:effectLst/>
-      </p:bgPr>
-    </p:bg>
-    <p:spTree>
-      <p:nvGrpSpPr>
-        <p:cNvPr id="1" name=""/>
-        <p:cNvGrpSpPr/>
-        <p:nvPr/>
-      </p:nvGrpSpPr>
-      <p:grpSpPr/>
-      <p:sp>
-        <p:nvSpPr>
-          <p:cNvPr id="2" name="TextBox 1"/>
-          <p:cNvSpPr txBox="1"/>
-          <p:nvPr/>
-        </p:nvSpPr>
-        <p:spPr>
-          <a:xfrm>
-            <a:off x="731520" y="365760"/>
-            <a:ext cx="10728655" cy="914400"/>
-          </a:xfrm>
-          <a:prstGeom prst="rect">
-            <a:avLst/>
-          </a:prstGeom>
-          <a:noFill/>
-        </p:spPr>
-        <p:txBody>
-          <a:bodyPr wrap="square"/>
-          <a:lstStyle/>
-          <a:p>
-            <a:pPr algn="l"/>
-            <a:r>
-              <a:rPr sz="2800" b="1" i="0">
-                <a:solidFill>
-                  <a:srgbClr val="FFFFFF"/>
-                </a:solidFill>
-                <a:latin typeface="Lato"/>
-              </a:rPr>
-              <a:t>Step B8: Start Claude Code</a:t>
-            </a:r>
-          </a:p>
-        </p:txBody>
-      </p:sp>
-      <p:sp>
-        <p:nvSpPr>
-          <p:cNvPr id="3" name="Rounded Rectangle 2"/>
-          <p:cNvSpPr/>
-          <p:nvPr/>
-        </p:nvSpPr>
-        <p:spPr>
-          <a:xfrm>
-            <a:off x="640080" y="1463040"/>
-            <a:ext cx="10911535" cy="4937760"/>
-          </a:xfrm>
-          <a:prstGeom prst="roundRect">
-            <a:avLst>
-              <a:gd name="adj" fmla="val 2000"/>
-            </a:avLst>
-          </a:prstGeom>
-          <a:solidFill>
-            <a:srgbClr val="16213E"/>
-          </a:solidFill>
-          <a:ln>
-            <a:noFill/>
-          </a:ln>
-        </p:spPr>
-        <p:style>
-          <a:lnRef idx="1">
-            <a:schemeClr val="accent1"/>
-          </a:lnRef>
-          <a:fillRef idx="3">
-            <a:schemeClr val="accent1"/>
-          </a:fillRef>
-          <a:effectRef idx="2">
-            <a:schemeClr val="accent1"/>
-          </a:effectRef>
-          <a:fontRef idx="minor">
-            <a:schemeClr val="lt1"/>
-          </a:fontRef>
-        </p:style>
-        <p:txBody>
-          <a:bodyPr rtlCol="0" anchor="ctr"/>
-          <a:lstStyle/>
-          <a:p>
-            <a:pPr algn="ctr"/>
-          </a:p>
-        </p:txBody>
-      </p:sp>
-      <p:sp>
-        <p:nvSpPr>
-          <p:cNvPr id="4" name="TextBox 3"/>
-          <p:cNvSpPr txBox="1"/>
-          <p:nvPr/>
-        </p:nvSpPr>
-        <p:spPr>
-          <a:xfrm>
-            <a:off x="914400" y="1645920"/>
-            <a:ext cx="10545775" cy="4572000"/>
-          </a:xfrm>
-          <a:prstGeom prst="rect">
-            <a:avLst/>
-          </a:prstGeom>
-          <a:noFill/>
-        </p:spPr>
-        <p:txBody>
-          <a:bodyPr wrap="square"/>
-          <a:lstStyle/>
-          <a:p>
-            <a:pPr>
-              <a:spcAft>
-                <a:spcPts val="200"/>
-              </a:spcAft>
-            </a:pPr>
-            <a:r>
-              <a:rPr sz="1400" b="0" i="0">
-                <a:solidFill>
-                  <a:srgbClr val="E0E0E0"/>
-                </a:solidFill>
-                <a:latin typeface="Consolas"/>
-              </a:rPr>
-              <a:t>claude</a:t>
-            </a:r>
-          </a:p>
-        </p:txBody>
-      </p:sp>
-    </p:spTree>
-  </p:cSld>
-  <p:clrMapOvr>
-    <a:masterClrMapping/>
-  </p:clrMapOvr>
-</p:sld>
-</file>
-
-<file path=ppt/slides/slide25.xml><?xml version="1.0" encoding="utf-8"?>
-<p:sld xmlns:a="http://schemas.openxmlformats.org/drawingml/2006/main" xmlns:p="http://schemas.openxmlformats.org/presentationml/2006/main" xmlns:r="http://schemas.openxmlformats.org/officeDocument/2006/relationships">
-  <p:cSld>
-    <p:bg>
-      <p:bgPr>
-        <a:solidFill>
-          <a:srgbClr val="1A1A2E"/>
-        </a:solidFill>
-        <a:effectLst/>
-      </p:bgPr>
-    </p:bg>
-    <p:spTree>
-      <p:nvGrpSpPr>
-        <p:cNvPr id="1" name=""/>
-        <p:cNvGrpSpPr/>
-        <p:nvPr/>
-      </p:nvGrpSpPr>
-      <p:grpSpPr/>
-      <p:sp>
-        <p:nvSpPr>
-          <p:cNvPr id="2" name="TextBox 1"/>
-          <p:cNvSpPr txBox="1"/>
-          <p:nvPr/>
-        </p:nvSpPr>
-        <p:spPr>
-          <a:xfrm>
-            <a:off x="914400" y="2560320"/>
-            <a:ext cx="10362895" cy="1371600"/>
-          </a:xfrm>
-          <a:prstGeom prst="rect">
-            <a:avLst/>
-          </a:prstGeom>
-          <a:noFill/>
-        </p:spPr>
-        <p:txBody>
-          <a:bodyPr wrap="square">
-            <a:spAutoFit/>
-          </a:bodyPr>
-          <a:lstStyle/>
-          <a:p>
-            <a:pPr algn="ctr"/>
-            <a:r>
-              <a:rPr sz="3200" b="1" i="0">
-                <a:solidFill>
-                  <a:srgbClr val="FFFFFF"/>
-                </a:solidFill>
-                <a:latin typeface="Lato"/>
-              </a:rPr>
-              <a:t>Step B8: Start Claude Code</a:t>
-            </a:r>
-          </a:p>
-        </p:txBody>
-      </p:sp>
-      <p:sp>
-        <p:nvSpPr>
-          <p:cNvPr id="3" name="Rectangle 2"/>
-          <p:cNvSpPr/>
-          <p:nvPr/>
-        </p:nvSpPr>
-        <p:spPr>
-          <a:xfrm>
-            <a:off x="4724247" y="4114800"/>
-            <a:ext cx="2743200" cy="54864"/>
-          </a:xfrm>
-          <a:prstGeom prst="rect">
-            <a:avLst/>
-          </a:prstGeom>
-          <a:solidFill>
-            <a:srgbClr val="4A90D9"/>
-          </a:solidFill>
-          <a:ln>
-            <a:noFill/>
-          </a:ln>
-        </p:spPr>
-        <p:style>
-          <a:lnRef idx="1">
-            <a:schemeClr val="accent1"/>
-          </a:lnRef>
-          <a:fillRef idx="3">
-            <a:schemeClr val="accent1"/>
-          </a:fillRef>
-          <a:effectRef idx="2">
-            <a:schemeClr val="accent1"/>
-          </a:effectRef>
-          <a:fontRef idx="minor">
-            <a:schemeClr val="lt1"/>
-          </a:fontRef>
-        </p:style>
-        <p:txBody>
-          <a:bodyPr rtlCol="0" anchor="ctr"/>
-          <a:lstStyle/>
-          <a:p>
-            <a:pPr algn="ctr"/>
-          </a:p>
-        </p:txBody>
-      </p:sp>
-    </p:spTree>
-  </p:cSld>
-  <p:clrMapOvr>
-    <a:masterClrMapping/>
-  </p:clrMapOvr>
-</p:sld>
-</file>
-
-<file path=ppt/slides/slide26.xml><?xml version="1.0" encoding="utf-8"?>
-<p:sld xmlns:a="http://schemas.openxmlformats.org/drawingml/2006/main" xmlns:p="http://schemas.openxmlformats.org/presentationml/2006/main" xmlns:r="http://schemas.openxmlformats.org/officeDocument/2006/relationships">
-  <p:cSld>
-    <p:bg>
-      <p:bgPr>
-        <a:solidFill>
-          <a:srgbClr val="1A1A2E"/>
-        </a:solidFill>
-        <a:effectLst/>
-      </p:bgPr>
-    </p:bg>
-    <p:spTree>
-      <p:nvGrpSpPr>
-        <p:cNvPr id="1" name=""/>
-        <p:cNvGrpSpPr/>
-        <p:nvPr/>
-      </p:nvGrpSpPr>
-      <p:grpSpPr/>
-      <p:sp>
-        <p:nvSpPr>
-          <p:cNvPr id="2" name="TextBox 1"/>
-          <p:cNvSpPr txBox="1"/>
-          <p:nvPr/>
-        </p:nvSpPr>
-        <p:spPr>
-          <a:xfrm>
-            <a:off x="914400" y="2560320"/>
-            <a:ext cx="10362895" cy="1371600"/>
-          </a:xfrm>
-          <a:prstGeom prst="rect">
-            <a:avLst/>
-          </a:prstGeom>
-          <a:noFill/>
-        </p:spPr>
-        <p:txBody>
-          <a:bodyPr wrap="square">
-            <a:spAutoFit/>
-          </a:bodyPr>
-          <a:lstStyle/>
-          <a:p>
-            <a:pPr algn="ctr"/>
-            <a:r>
-              <a:rPr sz="3200" b="1" i="0">
-                <a:solidFill>
-                  <a:srgbClr val="FFFFFF"/>
-                </a:solidFill>
-                <a:latin typeface="Lato"/>
-              </a:rPr>
-              <a:t>You're Ready!</a:t>
-            </a:r>
-          </a:p>
-        </p:txBody>
-      </p:sp>
-      <p:sp>
-        <p:nvSpPr>
-          <p:cNvPr id="3" name="Rectangle 2"/>
-          <p:cNvSpPr/>
-          <p:nvPr/>
-        </p:nvSpPr>
-        <p:spPr>
-          <a:xfrm>
-            <a:off x="4724247" y="4114800"/>
-            <a:ext cx="2743200" cy="54864"/>
-          </a:xfrm>
-          <a:prstGeom prst="rect">
-            <a:avLst/>
-          </a:prstGeom>
-          <a:solidFill>
-            <a:srgbClr val="4A90D9"/>
-          </a:solidFill>
-          <a:ln>
-            <a:noFill/>
-          </a:ln>
-        </p:spPr>
-        <p:style>
-          <a:lnRef idx="1">
-            <a:schemeClr val="accent1"/>
-          </a:lnRef>
-          <a:fillRef idx="3">
-            <a:schemeClr val="accent1"/>
-          </a:fillRef>
-          <a:effectRef idx="2">
-            <a:schemeClr val="accent1"/>
-          </a:effectRef>
-          <a:fontRef idx="minor">
-            <a:schemeClr val="lt1"/>
-          </a:fontRef>
-        </p:style>
-        <p:txBody>
-          <a:bodyPr rtlCol="0" anchor="ctr"/>
-          <a:lstStyle/>
-          <a:p>
-            <a:pPr algn="ctr"/>
-          </a:p>
-        </p:txBody>
-      </p:sp>
-    </p:spTree>
-  </p:cSld>
-  <p:clrMapOvr>
-    <a:masterClrMapping/>
-  </p:clrMapOvr>
-</p:sld>
-</file>
-
-<file path=ppt/slides/slide27.xml><?xml version="1.0" encoding="utf-8"?>
-<p:sld xmlns:a="http://schemas.openxmlformats.org/drawingml/2006/main" xmlns:p="http://schemas.openxmlformats.org/presentationml/2006/main" xmlns:r="http://schemas.openxmlformats.org/officeDocument/2006/relationships">
-  <p:cSld>
-    <p:bg>
-      <p:bgPr>
-        <a:solidFill>
-          <a:srgbClr val="1A1A2E"/>
-        </a:solidFill>
-        <a:effectLst/>
-      </p:bgPr>
-    </p:bg>
-    <p:spTree>
-      <p:nvGrpSpPr>
-        <p:cNvPr id="1" name=""/>
-        <p:cNvGrpSpPr/>
-        <p:nvPr/>
-      </p:nvGrpSpPr>
-      <p:grpSpPr/>
-      <p:sp>
-        <p:nvSpPr>
-          <p:cNvPr id="2" name="TextBox 1"/>
-          <p:cNvSpPr txBox="1"/>
-          <p:nvPr/>
-        </p:nvSpPr>
-        <p:spPr>
-          <a:xfrm>
-            <a:off x="731520" y="365760"/>
-            <a:ext cx="10728655" cy="914400"/>
-          </a:xfrm>
-          <a:prstGeom prst="rect">
-            <a:avLst/>
-          </a:prstGeom>
-          <a:noFill/>
-        </p:spPr>
-        <p:txBody>
-          <a:bodyPr wrap="square"/>
-          <a:lstStyle/>
-          <a:p>
-            <a:pPr algn="l"/>
-            <a:r>
-              <a:rPr sz="2800" b="1" i="0">
-                <a:solidFill>
-                  <a:srgbClr val="FFFFFF"/>
-                </a:solidFill>
-                <a:latin typeface="Lato"/>
-              </a:rPr>
-              <a:t>How to Know It Worked</a:t>
-            </a:r>
-          </a:p>
-        </p:txBody>
-      </p:sp>
-      <p:sp>
-        <p:nvSpPr>
-          <p:cNvPr id="3" name="Rectangle 2"/>
-          <p:cNvSpPr/>
-          <p:nvPr/>
-        </p:nvSpPr>
-        <p:spPr>
-          <a:xfrm>
-            <a:off x="5181447" y="1325880"/>
-            <a:ext cx="1828800" cy="54864"/>
-          </a:xfrm>
-          <a:prstGeom prst="rect">
-            <a:avLst/>
-          </a:prstGeom>
-          <a:solidFill>
-            <a:srgbClr val="4A90D9"/>
-          </a:solidFill>
-          <a:ln>
-            <a:noFill/>
-          </a:ln>
-        </p:spPr>
-        <p:style>
-          <a:lnRef idx="1">
-            <a:schemeClr val="accent1"/>
-          </a:lnRef>
-          <a:fillRef idx="3">
-            <a:schemeClr val="accent1"/>
-          </a:fillRef>
-          <a:effectRef idx="2">
-            <a:schemeClr val="accent1"/>
-          </a:effectRef>
-          <a:fontRef idx="minor">
-            <a:schemeClr val="lt1"/>
-          </a:fontRef>
-        </p:style>
-        <p:txBody>
-          <a:bodyPr rtlCol="0" anchor="ctr"/>
-          <a:lstStyle/>
-          <a:p>
-            <a:pPr algn="ctr"/>
-          </a:p>
-        </p:txBody>
-      </p:sp>
-      <p:sp>
-        <p:nvSpPr>
-          <p:cNvPr id="4" name="TextBox 3"/>
-          <p:cNvSpPr txBox="1"/>
-          <p:nvPr/>
-        </p:nvSpPr>
-        <p:spPr>
-          <a:xfrm>
-            <a:off x="731520" y="1645920"/>
-            <a:ext cx="10728655" cy="4754880"/>
-          </a:xfrm>
-          <a:prstGeom prst="rect">
-            <a:avLst/>
-          </a:prstGeom>
-          <a:noFill/>
-        </p:spPr>
-        <p:txBody>
-          <a:bodyPr wrap="square"/>
-          <a:lstStyle/>
-          <a:p>
-            <a:pPr algn="l">
-              <a:spcAft>
-                <a:spcPts val="1000"/>
-              </a:spcAft>
-            </a:pPr>
-            <a:r>
-              <a:rPr sz="1800" b="1" i="0">
-                <a:solidFill>
-                  <a:srgbClr val="4A90D9"/>
-                </a:solidFill>
-                <a:latin typeface="Lato"/>
-              </a:rPr>
-              <a:t>•  Desktop app:</a:t>
-            </a:r>
-            <a:r>
-              <a:rPr sz="1800" b="0" i="0">
-                <a:solidFill>
-                  <a:srgbClr val="E0E0E0"/>
-                </a:solidFill>
-                <a:latin typeface="Lato"/>
-              </a:rPr>
-              <a:t> You can open Claude Desktop and chat with Claude</a:t>
-            </a:r>
-          </a:p>
-          <a:p>
-            <a:pPr algn="l">
-              <a:spcAft>
-                <a:spcPts val="1000"/>
-              </a:spcAft>
-            </a:pPr>
-            <a:r>
-              <a:rPr sz="1800" b="1" i="0">
-                <a:solidFill>
-                  <a:srgbClr val="4A90D9"/>
-                </a:solidFill>
-                <a:latin typeface="Lato"/>
-              </a:rPr>
-              <a:t>•  Terminal:</a:t>
-            </a:r>
-            <a:r>
-              <a:rPr sz="1800" b="0" i="0">
-                <a:solidFill>
-                  <a:srgbClr val="E0E0E0"/>
-                </a:solidFill>
-                <a:latin typeface="Lato"/>
-              </a:rPr>
-              <a:t> You can type `claude` in Warp and it starts up</a:t>
-            </a:r>
-          </a:p>
-        </p:txBody>
-      </p:sp>
-    </p:spTree>
-  </p:cSld>
-  <p:clrMapOvr>
-    <a:masterClrMapping/>
-  </p:clrMapOvr>
-</p:sld>
-</file>
-
-<file path=ppt/slides/slide28.xml><?xml version="1.0" encoding="utf-8"?>
-<p:sld xmlns:a="http://schemas.openxmlformats.org/drawingml/2006/main" xmlns:p="http://schemas.openxmlformats.org/presentationml/2006/main" xmlns:r="http://schemas.openxmlformats.org/officeDocument/2006/relationships">
-  <p:cSld>
-    <p:bg>
-      <p:bgPr>
-        <a:solidFill>
-          <a:srgbClr val="1A1A2E"/>
-        </a:solidFill>
-        <a:effectLst/>
-      </p:bgPr>
-    </p:bg>
-    <p:spTree>
-      <p:nvGrpSpPr>
-        <p:cNvPr id="1" name=""/>
-        <p:cNvGrpSpPr/>
-        <p:nvPr/>
-      </p:nvGrpSpPr>
-      <p:grpSpPr/>
-      <p:sp>
-        <p:nvSpPr>
-          <p:cNvPr id="2" name="TextBox 1"/>
-          <p:cNvSpPr txBox="1"/>
-          <p:nvPr/>
-        </p:nvSpPr>
-        <p:spPr>
-          <a:xfrm>
-            <a:off x="731520" y="365760"/>
-            <a:ext cx="10728655" cy="914400"/>
-          </a:xfrm>
-          <a:prstGeom prst="rect">
-            <a:avLst/>
-          </a:prstGeom>
-          <a:noFill/>
-        </p:spPr>
-        <p:txBody>
-          <a:bodyPr wrap="square"/>
-          <a:lstStyle/>
-          <a:p>
-            <a:pPr algn="l"/>
-            <a:r>
-              <a:rPr sz="2800" b="1" i="0">
-                <a:solidFill>
-                  <a:srgbClr val="FFFFFF"/>
-                </a:solidFill>
-                <a:latin typeface="Lato"/>
-              </a:rPr>
               <a:t>Troubleshooting</a:t>
             </a:r>
           </a:p>
@@ -6116,7 +4804,7 @@
         </p:nvGraphicFramePr>
         <p:xfrm>
           <a:off x="731520" y="1645920"/>
-          <a:ext cx="10728655" cy="2880360"/>
+          <a:ext cx="10728655" cy="2468880"/>
         </p:xfrm>
         <a:graphic>
           <a:graphicData uri="http://schemas.openxmlformats.org/drawingml/2006/table">
@@ -6167,7 +4855,7 @@
                         </a:defRPr>
                       </a:pPr>
                       <a:r>
-                        <a:t>Solution</a:t>
+                        <a:t>What to do</a:t>
                       </a:r>
                     </a:p>
                   </a:txBody>
@@ -6193,7 +4881,7 @@
                         </a:defRPr>
                       </a:pPr>
                       <a:r>
-                        <a:t>`npm: command not found`</a:t>
+                        <a:t>`claude: command not found`</a:t>
                       </a:r>
                     </a:p>
                   </a:txBody>
@@ -6217,7 +4905,7 @@
                         </a:defRPr>
                       </a:pPr>
                       <a:r>
-                        <a:t>Install Node.js first (Step B6), then close and reopen Warp</a:t>
+                        <a:t>Close Warp completely, reopen it, try again</a:t>
                       </a:r>
                     </a:p>
                   </a:txBody>
@@ -6243,7 +4931,7 @@
                         </a:defRPr>
                       </a:pPr>
                       <a:r>
-                        <a:t>`Permission denied` on Mac</a:t>
+                        <a:t>`npm: command not found` or `Permission denied`</a:t>
                       </a:r>
                     </a:p>
                   </a:txBody>
@@ -6267,7 +4955,7 @@
                         </a:defRPr>
                       </a:pPr>
                       <a:r>
-                        <a:t>Add `sudo` in front: `sudo npm install -g @anthropic-ai/claude-code` — enter your computer password when asked</a:t>
+                        <a:t>Paste the exact error into Claude Desktop and ask what to do</a:t>
                       </a:r>
                     </a:p>
                   </a:txBody>
@@ -6293,7 +4981,7 @@
                         </a:defRPr>
                       </a:pPr>
                       <a:r>
-                        <a:t>`Permission denied` on Windows</a:t>
+                        <a:t>Can't sign in to Claude</a:t>
                       </a:r>
                     </a:p>
                   </a:txBody>
@@ -6317,7 +5005,7 @@
                         </a:defRPr>
                       </a:pPr>
                       <a:r>
-                        <a:t>Close Warp, right-click it, choose **Run as Administrator**, then try again</a:t>
+                        <a:t>Make sure you have an active Pro or Max subscription at claude.ai</a:t>
                       </a:r>
                     </a:p>
                   </a:txBody>
@@ -6343,7 +5031,7 @@
                         </a:defRPr>
                       </a:pPr>
                       <a:r>
-                        <a:t>`claude: command not found`</a:t>
+                        <a:t>Warp not installed</a:t>
                       </a:r>
                     </a:p>
                   </a:txBody>
@@ -6367,7 +5055,7 @@
                         </a:defRPr>
                       </a:pPr>
                       <a:r>
-                        <a:t>Close Warp completely and reopen it, then try `claude` again</a:t>
+                        <a:t>Download free from **warp.dev**</a:t>
                       </a:r>
                     </a:p>
                   </a:txBody>
@@ -6393,7 +5081,7 @@
                         </a:defRPr>
                       </a:pPr>
                       <a:r>
-                        <a:t>Can't sign in</a:t>
+                        <a:t>Tried everything, still stuck</a:t>
                       </a:r>
                     </a:p>
                   </a:txBody>
@@ -6417,63 +5105,13 @@
                         </a:defRPr>
                       </a:pPr>
                       <a:r>
-                        <a:t>Make sure you have an active Claude Pro or Max subscription at claude.ai</a:t>
+                        <a:t>Screenshot the error and message **#learning-pods** on Slack</a:t>
                       </a:r>
                     </a:p>
                   </a:txBody>
                   <a:tcPr>
                     <a:solidFill>
                       <a:srgbClr val="16213E"/>
-                    </a:solidFill>
-                  </a:tcPr>
-                </a:tc>
-              </a:tr>
-              <a:tr h="411480">
-                <a:tc>
-                  <a:txBody>
-                    <a:bodyPr/>
-                    <a:lstStyle/>
-                    <a:p>
-                      <a:pPr>
-                        <a:defRPr sz="1200">
-                          <a:solidFill>
-                            <a:srgbClr val="E0E0E0"/>
-                          </a:solidFill>
-                          <a:latin typeface="Lato"/>
-                        </a:defRPr>
-                      </a:pPr>
-                      <a:r>
-                        <a:t>Git Bash not showing in Warp</a:t>
-                      </a:r>
-                    </a:p>
-                  </a:txBody>
-                  <a:tcPr>
-                    <a:solidFill>
-                      <a:srgbClr val="1A1A2E"/>
-                    </a:solidFill>
-                  </a:tcPr>
-                </a:tc>
-                <a:tc>
-                  <a:txBody>
-                    <a:bodyPr/>
-                    <a:lstStyle/>
-                    <a:p>
-                      <a:pPr>
-                        <a:defRPr sz="1200">
-                          <a:solidFill>
-                            <a:srgbClr val="E0E0E0"/>
-                          </a:solidFill>
-                          <a:latin typeface="Lato"/>
-                        </a:defRPr>
-                      </a:pPr>
-                      <a:r>
-                        <a:t>Install Git for Windows from git-scm.com, then restart Warp</a:t>
-                      </a:r>
-                    </a:p>
-                  </a:txBody>
-                  <a:tcPr>
-                    <a:solidFill>
-                      <a:srgbClr val="1A1A2E"/>
                     </a:solidFill>
                   </a:tcPr>
                 </a:tc>
@@ -6490,7 +5128,7 @@
 </p:sld>
 </file>
 
-<file path=ppt/slides/slide29.xml><?xml version="1.0" encoding="utf-8"?>
+<file path=ppt/slides/slide2.xml><?xml version="1.0" encoding="utf-8"?>
 <p:sld xmlns:a="http://schemas.openxmlformats.org/drawingml/2006/main" xmlns:p="http://schemas.openxmlformats.org/presentationml/2006/main" xmlns:r="http://schemas.openxmlformats.org/officeDocument/2006/relationships">
   <p:cSld>
     <p:bg>
@@ -6538,7 +5176,7 @@
                 </a:solidFill>
                 <a:latin typeface="Lato"/>
               </a:rPr>
-              <a:t>Troubleshooting</a:t>
+              <a:t>What You Need Before Starting</a:t>
             </a:r>
           </a:p>
         </p:txBody>
@@ -6583,6 +5221,181 @@
           <a:lstStyle/>
           <a:p>
             <a:pPr algn="ctr"/>
+          </a:p>
+        </p:txBody>
+      </p:sp>
+    </p:spTree>
+  </p:cSld>
+  <p:clrMapOvr>
+    <a:masterClrMapping/>
+  </p:clrMapOvr>
+</p:sld>
+</file>
+
+<file path=ppt/slides/slide20.xml><?xml version="1.0" encoding="utf-8"?>
+<p:sld xmlns:a="http://schemas.openxmlformats.org/drawingml/2006/main" xmlns:p="http://schemas.openxmlformats.org/presentationml/2006/main" xmlns:r="http://schemas.openxmlformats.org/officeDocument/2006/relationships">
+  <p:cSld>
+    <p:bg>
+      <p:bgPr>
+        <a:solidFill>
+          <a:srgbClr val="1A1A2E"/>
+        </a:solidFill>
+        <a:effectLst/>
+      </p:bgPr>
+    </p:bg>
+    <p:spTree>
+      <p:nvGrpSpPr>
+        <p:cNvPr id="1" name=""/>
+        <p:cNvGrpSpPr/>
+        <p:nvPr/>
+      </p:nvGrpSpPr>
+      <p:grpSpPr/>
+      <p:sp>
+        <p:nvSpPr>
+          <p:cNvPr id="2" name="TextBox 1"/>
+          <p:cNvSpPr txBox="1"/>
+          <p:nvPr/>
+        </p:nvSpPr>
+        <p:spPr>
+          <a:xfrm>
+            <a:off x="731520" y="365760"/>
+            <a:ext cx="10728655" cy="914400"/>
+          </a:xfrm>
+          <a:prstGeom prst="rect">
+            <a:avLst/>
+          </a:prstGeom>
+          <a:noFill/>
+        </p:spPr>
+        <p:txBody>
+          <a:bodyPr wrap="square"/>
+          <a:lstStyle/>
+          <a:p>
+            <a:pPr algn="l"/>
+            <a:r>
+              <a:rPr sz="2800" b="1" i="0">
+                <a:solidFill>
+                  <a:srgbClr val="FFFFFF"/>
+                </a:solidFill>
+                <a:latin typeface="Lato"/>
+              </a:rPr>
+              <a:t>What's Next?</a:t>
+            </a:r>
+          </a:p>
+        </p:txBody>
+      </p:sp>
+      <p:sp>
+        <p:nvSpPr>
+          <p:cNvPr id="3" name="Rectangle 2"/>
+          <p:cNvSpPr/>
+          <p:nvPr/>
+        </p:nvSpPr>
+        <p:spPr>
+          <a:xfrm>
+            <a:off x="5181447" y="1325880"/>
+            <a:ext cx="1828800" cy="54864"/>
+          </a:xfrm>
+          <a:prstGeom prst="rect">
+            <a:avLst/>
+          </a:prstGeom>
+          <a:solidFill>
+            <a:srgbClr val="4A90D9"/>
+          </a:solidFill>
+          <a:ln>
+            <a:noFill/>
+          </a:ln>
+        </p:spPr>
+        <p:style>
+          <a:lnRef idx="1">
+            <a:schemeClr val="accent1"/>
+          </a:lnRef>
+          <a:fillRef idx="3">
+            <a:schemeClr val="accent1"/>
+          </a:fillRef>
+          <a:effectRef idx="2">
+            <a:schemeClr val="accent1"/>
+          </a:effectRef>
+          <a:fontRef idx="minor">
+            <a:schemeClr val="lt1"/>
+          </a:fontRef>
+        </p:style>
+        <p:txBody>
+          <a:bodyPr rtlCol="0" anchor="ctr"/>
+          <a:lstStyle/>
+          <a:p>
+            <a:pPr algn="ctr"/>
+          </a:p>
+        </p:txBody>
+      </p:sp>
+      <p:sp>
+        <p:nvSpPr>
+          <p:cNvPr id="4" name="TextBox 3"/>
+          <p:cNvSpPr txBox="1"/>
+          <p:nvPr/>
+        </p:nvSpPr>
+        <p:spPr>
+          <a:xfrm>
+            <a:off x="731520" y="1645920"/>
+            <a:ext cx="10728655" cy="4754880"/>
+          </a:xfrm>
+          <a:prstGeom prst="rect">
+            <a:avLst/>
+          </a:prstGeom>
+          <a:noFill/>
+        </p:spPr>
+        <p:txBody>
+          <a:bodyPr wrap="square"/>
+          <a:lstStyle/>
+          <a:p>
+            <a:pPr algn="l">
+              <a:spcAft>
+                <a:spcPts val="1000"/>
+              </a:spcAft>
+            </a:pPr>
+            <a:r>
+              <a:rPr sz="1800" b="0" i="0">
+                <a:solidFill>
+                  <a:srgbClr val="E0E0E0"/>
+                </a:solidFill>
+                <a:latin typeface="Lato"/>
+              </a:rPr>
+              <a:t>•  Come to </a:t>
+            </a:r>
+            <a:r>
+              <a:rPr sz="1800" b="1" i="0">
+                <a:solidFill>
+                  <a:srgbClr val="4A90D9"/>
+                </a:solidFill>
+                <a:latin typeface="Lato"/>
+              </a:rPr>
+              <a:t>Pod 01: Hello, Terminal</a:t>
+            </a:r>
+            <a:r>
+              <a:rPr sz="1800" b="0" i="0">
+                <a:solidFill>
+                  <a:srgbClr val="E0E0E0"/>
+                </a:solidFill>
+                <a:latin typeface="Lato"/>
+              </a:rPr>
+              <a:t> with this setup done — if you get stuck, message </a:t>
+            </a:r>
+            <a:r>
+              <a:rPr sz="1800" b="1" i="0">
+                <a:solidFill>
+                  <a:srgbClr val="4A90D9"/>
+                </a:solidFill>
+                <a:latin typeface="Lato"/>
+              </a:rPr>
+              <a:t>#learning-pods</a:t>
+            </a:r>
+            <a:r>
+              <a:rPr sz="1800" b="0" i="0">
+                <a:solidFill>
+                  <a:srgbClr val="E0E0E0"/>
+                </a:solidFill>
+                <a:latin typeface="Lato"/>
+              </a:rPr>
+              <a:t> on Slack</a:t>
+            </a:r>
           </a:p>
         </p:txBody>
       </p:sp>
@@ -6698,110 +5511,6 @@
 </p:sld>
 </file>
 
-<file path=ppt/slides/slide30.xml><?xml version="1.0" encoding="utf-8"?>
-<p:sld xmlns:a="http://schemas.openxmlformats.org/drawingml/2006/main" xmlns:p="http://schemas.openxmlformats.org/presentationml/2006/main" xmlns:r="http://schemas.openxmlformats.org/officeDocument/2006/relationships">
-  <p:cSld>
-    <p:bg>
-      <p:bgPr>
-        <a:solidFill>
-          <a:srgbClr val="1A1A2E"/>
-        </a:solidFill>
-        <a:effectLst/>
-      </p:bgPr>
-    </p:bg>
-    <p:spTree>
-      <p:nvGrpSpPr>
-        <p:cNvPr id="1" name=""/>
-        <p:cNvGrpSpPr/>
-        <p:nvPr/>
-      </p:nvGrpSpPr>
-      <p:grpSpPr/>
-      <p:sp>
-        <p:nvSpPr>
-          <p:cNvPr id="2" name="TextBox 1"/>
-          <p:cNvSpPr txBox="1"/>
-          <p:nvPr/>
-        </p:nvSpPr>
-        <p:spPr>
-          <a:xfrm>
-            <a:off x="914400" y="2560320"/>
-            <a:ext cx="10362895" cy="1371600"/>
-          </a:xfrm>
-          <a:prstGeom prst="rect">
-            <a:avLst/>
-          </a:prstGeom>
-          <a:noFill/>
-        </p:spPr>
-        <p:txBody>
-          <a:bodyPr wrap="square">
-            <a:spAutoFit/>
-          </a:bodyPr>
-          <a:lstStyle/>
-          <a:p>
-            <a:pPr algn="ctr"/>
-            <a:r>
-              <a:rPr sz="3200" b="1" i="0">
-                <a:solidFill>
-                  <a:srgbClr val="FFFFFF"/>
-                </a:solidFill>
-                <a:latin typeface="Lato"/>
-              </a:rPr>
-              <a:t>What's Next?</a:t>
-            </a:r>
-          </a:p>
-        </p:txBody>
-      </p:sp>
-      <p:sp>
-        <p:nvSpPr>
-          <p:cNvPr id="3" name="Rectangle 2"/>
-          <p:cNvSpPr/>
-          <p:nvPr/>
-        </p:nvSpPr>
-        <p:spPr>
-          <a:xfrm>
-            <a:off x="4724247" y="4114800"/>
-            <a:ext cx="2743200" cy="54864"/>
-          </a:xfrm>
-          <a:prstGeom prst="rect">
-            <a:avLst/>
-          </a:prstGeom>
-          <a:solidFill>
-            <a:srgbClr val="4A90D9"/>
-          </a:solidFill>
-          <a:ln>
-            <a:noFill/>
-          </a:ln>
-        </p:spPr>
-        <p:style>
-          <a:lnRef idx="1">
-            <a:schemeClr val="accent1"/>
-          </a:lnRef>
-          <a:fillRef idx="3">
-            <a:schemeClr val="accent1"/>
-          </a:fillRef>
-          <a:effectRef idx="2">
-            <a:schemeClr val="accent1"/>
-          </a:effectRef>
-          <a:fontRef idx="minor">
-            <a:schemeClr val="lt1"/>
-          </a:fontRef>
-        </p:style>
-        <p:txBody>
-          <a:bodyPr rtlCol="0" anchor="ctr"/>
-          <a:lstStyle/>
-          <a:p>
-            <a:pPr algn="ctr"/>
-          </a:p>
-        </p:txBody>
-      </p:sp>
-    </p:spTree>
-  </p:cSld>
-  <p:clrMapOvr>
-    <a:masterClrMapping/>
-  </p:clrMapOvr>
-</p:sld>
-</file>
-
 <file path=ppt/slides/slide4.xml><?xml version="1.0" encoding="utf-8"?>
 <p:sld xmlns:a="http://schemas.openxmlformats.org/drawingml/2006/main" xmlns:p="http://schemas.openxmlformats.org/presentationml/2006/main" xmlns:r="http://schemas.openxmlformats.org/officeDocument/2006/relationships">
   <p:cSld>
@@ -6828,8 +5537,8 @@
         </p:nvSpPr>
         <p:spPr>
           <a:xfrm>
-            <a:off x="914400" y="2560320"/>
-            <a:ext cx="10362895" cy="1371600"/>
+            <a:off x="731520" y="365760"/>
+            <a:ext cx="10728655" cy="914400"/>
           </a:xfrm>
           <a:prstGeom prst="rect">
             <a:avLst/>
@@ -6837,14 +5546,12 @@
           <a:noFill/>
         </p:spPr>
         <p:txBody>
-          <a:bodyPr wrap="square">
-            <a:spAutoFit/>
-          </a:bodyPr>
-          <a:lstStyle/>
-          <a:p>
-            <a:pPr algn="ctr"/>
-            <a:r>
-              <a:rPr sz="3200" b="1" i="0">
+          <a:bodyPr wrap="square"/>
+          <a:lstStyle/>
+          <a:p>
+            <a:pPr algn="l"/>
+            <a:r>
+              <a:rPr sz="2800" b="1" i="0">
                 <a:solidFill>
                   <a:srgbClr val="FFFFFF"/>
                 </a:solidFill>
@@ -6863,8 +5570,8 @@
         </p:nvSpPr>
         <p:spPr>
           <a:xfrm>
-            <a:off x="4724247" y="4114800"/>
-            <a:ext cx="2743200" cy="54864"/>
+            <a:off x="5181447" y="1325880"/>
+            <a:ext cx="1828800" cy="54864"/>
           </a:xfrm>
           <a:prstGeom prst="rect">
             <a:avLst/>
@@ -6895,6 +5602,127 @@
           <a:lstStyle/>
           <a:p>
             <a:pPr algn="ctr"/>
+          </a:p>
+        </p:txBody>
+      </p:sp>
+      <p:sp>
+        <p:nvSpPr>
+          <p:cNvPr id="4" name="TextBox 3"/>
+          <p:cNvSpPr txBox="1"/>
+          <p:nvPr/>
+        </p:nvSpPr>
+        <p:spPr>
+          <a:xfrm>
+            <a:off x="731520" y="1645920"/>
+            <a:ext cx="10728655" cy="4754880"/>
+          </a:xfrm>
+          <a:prstGeom prst="rect">
+            <a:avLst/>
+          </a:prstGeom>
+          <a:noFill/>
+        </p:spPr>
+        <p:txBody>
+          <a:bodyPr wrap="square"/>
+          <a:lstStyle/>
+          <a:p>
+            <a:pPr algn="l">
+              <a:spcAft>
+                <a:spcPts val="1000"/>
+              </a:spcAft>
+            </a:pPr>
+            <a:r>
+              <a:rPr sz="1800" b="1" i="0">
+                <a:solidFill>
+                  <a:srgbClr val="4A90D9"/>
+                </a:solidFill>
+                <a:latin typeface="Lato"/>
+              </a:rPr>
+              <a:t>•  Think of it like Google Drive, but for code</a:t>
+            </a:r>
+            <a:r>
+              <a:rPr sz="1800" b="0" i="0">
+                <a:solidFill>
+                  <a:srgbClr val="E0E0E0"/>
+                </a:solidFill>
+                <a:latin typeface="Lato"/>
+              </a:rPr>
+              <a:t> — it's where all course materials live and where your projects get saved</a:t>
+            </a:r>
+          </a:p>
+          <a:p>
+            <a:pPr algn="l">
+              <a:spcAft>
+                <a:spcPts val="1000"/>
+              </a:spcAft>
+            </a:pPr>
+            <a:r>
+              <a:rPr sz="1800" b="1" i="0">
+                <a:solidFill>
+                  <a:srgbClr val="4A90D9"/>
+                </a:solidFill>
+                <a:latin typeface="Lato"/>
+              </a:rPr>
+              <a:t>•  It remembers every version, forever</a:t>
+            </a:r>
+            <a:r>
+              <a:rPr sz="1800" b="0" i="0">
+                <a:solidFill>
+                  <a:srgbClr val="E0E0E0"/>
+                </a:solidFill>
+                <a:latin typeface="Lato"/>
+              </a:rPr>
+              <a:t> — unlike Word which overwrites your file each time you save, GitHub keeps the full history so you can always roll back if something breaks</a:t>
+            </a:r>
+          </a:p>
+          <a:p>
+            <a:pPr algn="l">
+              <a:spcAft>
+                <a:spcPts val="1000"/>
+              </a:spcAft>
+            </a:pPr>
+            <a:r>
+              <a:rPr sz="1800" b="1" i="0">
+                <a:solidFill>
+                  <a:srgbClr val="4A90D9"/>
+                </a:solidFill>
+                <a:latin typeface="Lato"/>
+              </a:rPr>
+              <a:t>•  It handles teamwork automatically</a:t>
+            </a:r>
+            <a:r>
+              <a:rPr sz="1800" b="0" i="0">
+                <a:solidFill>
+                  <a:srgbClr val="E0E0E0"/>
+                </a:solidFill>
+                <a:latin typeface="Lato"/>
+              </a:rPr>
+              <a:t> — if two people edit different parts of the same project, GitHub merges the changes without them overwriting each other</a:t>
+            </a:r>
+          </a:p>
+          <a:p>
+            <a:pPr algn="l">
+              <a:spcAft>
+                <a:spcPts val="1000"/>
+              </a:spcAft>
+            </a:pPr>
+            <a:r>
+              <a:rPr sz="1800" b="1" i="0">
+                <a:solidFill>
+                  <a:srgbClr val="4A90D9"/>
+                </a:solidFill>
+                <a:latin typeface="Lato"/>
+              </a:rPr>
+              <a:t>•  You don't need to touch it directly</a:t>
+            </a:r>
+            <a:r>
+              <a:rPr sz="1800" b="0" i="0">
+                <a:solidFill>
+                  <a:srgbClr val="E0E0E0"/>
+                </a:solidFill>
+                <a:latin typeface="Lato"/>
+              </a:rPr>
+              <a:t> — Claude Code manages all of this for you; you just need an account so your work saves to the right place</a:t>
+            </a:r>
           </a:p>
         </p:txBody>
       </p:sp>
@@ -7166,7 +5994,7 @@
                 </a:solidFill>
                 <a:latin typeface="Lato"/>
               </a:rPr>
-              <a:t>Complete the verification steps (usually a simple puzzle)</a:t>
+              <a:t>Complete the verification steps (a simple puzzle, then click the link in your @orennow.com email)</a:t>
             </a:r>
           </a:p>
         </p:txBody>
@@ -7205,8 +6033,8 @@
         </p:nvSpPr>
         <p:spPr>
           <a:xfrm>
-            <a:off x="731520" y="365760"/>
-            <a:ext cx="10728655" cy="914400"/>
+            <a:off x="914400" y="2560320"/>
+            <a:ext cx="10362895" cy="1371600"/>
           </a:xfrm>
           <a:prstGeom prst="rect">
             <a:avLst/>
@@ -7214,18 +6042,20 @@
           <a:noFill/>
         </p:spPr>
         <p:txBody>
-          <a:bodyPr wrap="square"/>
-          <a:lstStyle/>
-          <a:p>
-            <a:pPr algn="l"/>
-            <a:r>
-              <a:rPr sz="2800" b="1" i="0">
+          <a:bodyPr wrap="square">
+            <a:spAutoFit/>
+          </a:bodyPr>
+          <a:lstStyle/>
+          <a:p>
+            <a:pPr algn="ctr"/>
+            <a:r>
+              <a:rPr sz="3200" b="1" i="0">
                 <a:solidFill>
                   <a:srgbClr val="FFFFFF"/>
                 </a:solidFill>
                 <a:latin typeface="Lato"/>
               </a:rPr>
-              <a:t>How to Create Your Account (cont.)</a:t>
+              <a:t>Step 2: Install Warp Terminal</a:t>
             </a:r>
           </a:p>
         </p:txBody>
@@ -7238,8 +6068,8 @@
         </p:nvSpPr>
         <p:spPr>
           <a:xfrm>
-            <a:off x="5181447" y="1325880"/>
-            <a:ext cx="1828800" cy="54864"/>
+            <a:off x="4724247" y="4114800"/>
+            <a:ext cx="2743200" cy="54864"/>
           </a:xfrm>
           <a:prstGeom prst="rect">
             <a:avLst/>
@@ -7270,52 +6100,6 @@
           <a:lstStyle/>
           <a:p>
             <a:pPr algn="ctr"/>
-          </a:p>
-        </p:txBody>
-      </p:sp>
-      <p:sp>
-        <p:nvSpPr>
-          <p:cNvPr id="4" name="TextBox 3"/>
-          <p:cNvSpPr txBox="1"/>
-          <p:nvPr/>
-        </p:nvSpPr>
-        <p:spPr>
-          <a:xfrm>
-            <a:off x="731520" y="1645920"/>
-            <a:ext cx="10728655" cy="4754880"/>
-          </a:xfrm>
-          <a:prstGeom prst="rect">
-            <a:avLst/>
-          </a:prstGeom>
-          <a:noFill/>
-        </p:spPr>
-        <p:txBody>
-          <a:bodyPr wrap="square"/>
-          <a:lstStyle/>
-          <a:p>
-            <a:pPr algn="l">
-              <a:spcAft>
-                <a:spcPts val="1200"/>
-              </a:spcAft>
-            </a:pPr>
-            <a:r>
-              <a:rPr sz="1800" b="1" i="0">
-                <a:solidFill>
-                  <a:srgbClr val="4A90D9"/>
-                </a:solidFill>
-                <a:latin typeface="Lato"/>
-              </a:rPr>
-              <a:t>7.  </a:t>
-            </a:r>
-            <a:r>
-              <a:rPr sz="1800" b="0" i="0">
-                <a:solidFill>
-                  <a:srgbClr val="E0E0E0"/>
-                </a:solidFill>
-                <a:latin typeface="Lato"/>
-              </a:rPr>
-              <a:t>Check your @orennow.com email for a verification link and click it</a:t>
-            </a:r>
           </a:p>
         </p:txBody>
       </p:sp>
@@ -7353,8 +6137,8 @@
         </p:nvSpPr>
         <p:spPr>
           <a:xfrm>
-            <a:off x="914400" y="2560320"/>
-            <a:ext cx="10362895" cy="1371600"/>
+            <a:off x="731520" y="365760"/>
+            <a:ext cx="10728655" cy="914400"/>
           </a:xfrm>
           <a:prstGeom prst="rect">
             <a:avLst/>
@@ -7362,20 +6146,18 @@
           <a:noFill/>
         </p:spPr>
         <p:txBody>
-          <a:bodyPr wrap="square">
-            <a:spAutoFit/>
-          </a:bodyPr>
-          <a:lstStyle/>
-          <a:p>
-            <a:pPr algn="ctr"/>
-            <a:r>
-              <a:rPr sz="3200" b="1" i="0">
+          <a:bodyPr wrap="square"/>
+          <a:lstStyle/>
+          <a:p>
+            <a:pPr algn="l"/>
+            <a:r>
+              <a:rPr sz="2800" b="1" i="0">
                 <a:solidFill>
                   <a:srgbClr val="FFFFFF"/>
                 </a:solidFill>
                 <a:latin typeface="Lato"/>
               </a:rPr>
-              <a:t>Step 2: Install Claude Code</a:t>
+              <a:t>What is Warp?</a:t>
             </a:r>
           </a:p>
         </p:txBody>
@@ -7388,8 +6170,8 @@
         </p:nvSpPr>
         <p:spPr>
           <a:xfrm>
-            <a:off x="4724247" y="4114800"/>
-            <a:ext cx="2743200" cy="54864"/>
+            <a:off x="5181447" y="1325880"/>
+            <a:ext cx="1828800" cy="54864"/>
           </a:xfrm>
           <a:prstGeom prst="rect">
             <a:avLst/>
@@ -7420,6 +6202,68 @@
           <a:lstStyle/>
           <a:p>
             <a:pPr algn="ctr"/>
+          </a:p>
+        </p:txBody>
+      </p:sp>
+      <p:sp>
+        <p:nvSpPr>
+          <p:cNvPr id="4" name="TextBox 3"/>
+          <p:cNvSpPr txBox="1"/>
+          <p:nvPr/>
+        </p:nvSpPr>
+        <p:spPr>
+          <a:xfrm>
+            <a:off x="731520" y="1645920"/>
+            <a:ext cx="10728655" cy="4754880"/>
+          </a:xfrm>
+          <a:prstGeom prst="rect">
+            <a:avLst/>
+          </a:prstGeom>
+          <a:noFill/>
+        </p:spPr>
+        <p:txBody>
+          <a:bodyPr wrap="square"/>
+          <a:lstStyle/>
+          <a:p>
+            <a:pPr algn="l">
+              <a:spcAft>
+                <a:spcPts val="1000"/>
+              </a:spcAft>
+            </a:pPr>
+            <a:r>
+              <a:rPr sz="1800" b="1" i="0">
+                <a:solidFill>
+                  <a:srgbClr val="4A90D9"/>
+                </a:solidFill>
+                <a:latin typeface="Lato"/>
+              </a:rPr>
+              <a:t>•  Your terminal for the entire course</a:t>
+            </a:r>
+            <a:r>
+              <a:rPr sz="1800" b="0" i="0">
+                <a:solidFill>
+                  <a:srgbClr val="E0E0E0"/>
+                </a:solidFill>
+                <a:latin typeface="Lato"/>
+              </a:rPr>
+              <a:t> — a text box where you type instructions to your computer</a:t>
+            </a:r>
+          </a:p>
+          <a:p>
+            <a:pPr algn="l">
+              <a:spcAft>
+                <a:spcPts val="1000"/>
+              </a:spcAft>
+            </a:pPr>
+            <a:r>
+              <a:rPr sz="1800" b="0" i="0">
+                <a:solidFill>
+                  <a:srgbClr val="E0E0E0"/>
+                </a:solidFill>
+                <a:latin typeface="Lato"/>
+              </a:rPr>
+              <a:t>•  Free, works on Mac and Windows, and much friendlier than the default terminal</a:t>
+            </a:r>
           </a:p>
         </p:txBody>
       </p:sp>
@@ -7477,431 +6321,175 @@
                 </a:solidFill>
                 <a:latin typeface="Lato"/>
               </a:rPr>
-              <a:t>Pick Your Path</a:t>
-            </a:r>
-          </a:p>
-        </p:txBody>
-      </p:sp>
-      <p:graphicFrame>
-        <p:nvGraphicFramePr>
-          <p:cNvPr id="3" name="Table 2"/>
-          <p:cNvGraphicFramePr>
-            <a:graphicFrameLocks noGrp="1"/>
-          </p:cNvGraphicFramePr>
+              <a:t>Install Warp</a:t>
+            </a:r>
+          </a:p>
+        </p:txBody>
+      </p:sp>
+      <p:sp>
+        <p:nvSpPr>
+          <p:cNvPr id="3" name="Rectangle 2"/>
+          <p:cNvSpPr/>
           <p:nvPr/>
-        </p:nvGraphicFramePr>
-        <p:xfrm>
-          <a:off x="731520" y="1645920"/>
-          <a:ext cx="10728655" cy="1645920"/>
-        </p:xfrm>
-        <a:graphic>
-          <a:graphicData uri="http://schemas.openxmlformats.org/drawingml/2006/table">
-            <a:tbl>
-              <a:tblPr firstRow="1" bandRow="1">
-                <a:tableStyleId>{5C22544A-7EE6-4342-B048-85BDC9FD1C3A}</a:tableStyleId>
-              </a:tblPr>
-              <a:tblGrid>
-                <a:gridCol w="2682163"/>
-                <a:gridCol w="2682163"/>
-                <a:gridCol w="2682163"/>
-                <a:gridCol w="2682166"/>
-              </a:tblGrid>
-              <a:tr h="411480">
-                <a:tc>
-                  <a:txBody>
-                    <a:bodyPr/>
-                    <a:lstStyle/>
-                    <a:p>
-                      <a:pPr>
-                        <a:defRPr sz="1400" b="1">
-                          <a:solidFill>
-                            <a:srgbClr val="FFFFFF"/>
-                          </a:solidFill>
-                          <a:latin typeface="Lato"/>
-                        </a:defRPr>
-                      </a:pPr>
-                      <a:r>
-                        <a:t>Path</a:t>
-                      </a:r>
-                    </a:p>
-                  </a:txBody>
-                  <a:tcPr>
-                    <a:solidFill>
-                      <a:srgbClr val="1E2C56"/>
-                    </a:solidFill>
-                  </a:tcPr>
-                </a:tc>
-                <a:tc>
-                  <a:txBody>
-                    <a:bodyPr/>
-                    <a:lstStyle/>
-                    <a:p>
-                      <a:pPr>
-                        <a:defRPr sz="1400" b="1">
-                          <a:solidFill>
-                            <a:srgbClr val="FFFFFF"/>
-                          </a:solidFill>
-                          <a:latin typeface="Lato"/>
-                        </a:defRPr>
-                      </a:pPr>
-                      <a:r>
-                        <a:t>Best for</a:t>
-                      </a:r>
-                    </a:p>
-                  </a:txBody>
-                  <a:tcPr>
-                    <a:solidFill>
-                      <a:srgbClr val="1E2C56"/>
-                    </a:solidFill>
-                  </a:tcPr>
-                </a:tc>
-                <a:tc>
-                  <a:txBody>
-                    <a:bodyPr/>
-                    <a:lstStyle/>
-                    <a:p>
-                      <a:pPr>
-                        <a:defRPr sz="1400" b="1">
-                          <a:solidFill>
-                            <a:srgbClr val="FFFFFF"/>
-                          </a:solidFill>
-                          <a:latin typeface="Lato"/>
-                        </a:defRPr>
-                      </a:pPr>
-                      <a:r>
-                        <a:t>Time</a:t>
-                      </a:r>
-                    </a:p>
-                  </a:txBody>
-                  <a:tcPr>
-                    <a:solidFill>
-                      <a:srgbClr val="1E2C56"/>
-                    </a:solidFill>
-                  </a:tcPr>
-                </a:tc>
-                <a:tc>
-                  <a:txBody>
-                    <a:bodyPr/>
-                    <a:lstStyle/>
-                    <a:p>
-                      <a:pPr>
-                        <a:defRPr sz="1400" b="1">
-                          <a:solidFill>
-                            <a:srgbClr val="FFFFFF"/>
-                          </a:solidFill>
-                          <a:latin typeface="Lato"/>
-                        </a:defRPr>
-                      </a:pPr>
-                      <a:r>
-                        <a:t>What you get</a:t>
-                      </a:r>
-                    </a:p>
-                  </a:txBody>
-                  <a:tcPr>
-                    <a:solidFill>
-                      <a:srgbClr val="1E2C56"/>
-                    </a:solidFill>
-                  </a:tcPr>
-                </a:tc>
-              </a:tr>
-              <a:tr h="411480">
-                <a:tc>
-                  <a:txBody>
-                    <a:bodyPr/>
-                    <a:lstStyle/>
-                    <a:p>
-                      <a:pPr>
-                        <a:defRPr sz="1200">
-                          <a:solidFill>
-                            <a:srgbClr val="E0E0E0"/>
-                          </a:solidFill>
-                          <a:latin typeface="Lato"/>
-                        </a:defRPr>
-                      </a:pPr>
-                      <a:r>
-                        <a:t>**Path A: Desktop App**</a:t>
-                      </a:r>
-                    </a:p>
-                  </a:txBody>
-                  <a:tcPr>
-                    <a:solidFill>
-                      <a:srgbClr val="16213E"/>
-                    </a:solidFill>
-                  </a:tcPr>
-                </a:tc>
-                <a:tc>
-                  <a:txBody>
-                    <a:bodyPr/>
-                    <a:lstStyle/>
-                    <a:p>
-                      <a:pPr>
-                        <a:defRPr sz="1200">
-                          <a:solidFill>
-                            <a:srgbClr val="E0E0E0"/>
-                          </a:solidFill>
-                          <a:latin typeface="Lato"/>
-                        </a:defRPr>
-                      </a:pPr>
-                      <a:r>
-                        <a:t>Fastest setup</a:t>
-                      </a:r>
-                    </a:p>
-                  </a:txBody>
-                  <a:tcPr>
-                    <a:solidFill>
-                      <a:srgbClr val="16213E"/>
-                    </a:solidFill>
-                  </a:tcPr>
-                </a:tc>
-                <a:tc>
-                  <a:txBody>
-                    <a:bodyPr/>
-                    <a:lstStyle/>
-                    <a:p>
-                      <a:pPr>
-                        <a:defRPr sz="1200">
-                          <a:solidFill>
-                            <a:srgbClr val="E0E0E0"/>
-                          </a:solidFill>
-                          <a:latin typeface="Lato"/>
-                        </a:defRPr>
-                      </a:pPr>
-                      <a:r>
-                        <a:t>5 min</a:t>
-                      </a:r>
-                    </a:p>
-                  </a:txBody>
-                  <a:tcPr>
-                    <a:solidFill>
-                      <a:srgbClr val="16213E"/>
-                    </a:solidFill>
-                  </a:tcPr>
-                </a:tc>
-                <a:tc>
-                  <a:txBody>
-                    <a:bodyPr/>
-                    <a:lstStyle/>
-                    <a:p>
-                      <a:pPr>
-                        <a:defRPr sz="1200">
-                          <a:solidFill>
-                            <a:srgbClr val="E0E0E0"/>
-                          </a:solidFill>
-                          <a:latin typeface="Lato"/>
-                        </a:defRPr>
-                      </a:pPr>
-                      <a:r>
-                        <a:t>Claude in a window — like a chat app</a:t>
-                      </a:r>
-                    </a:p>
-                  </a:txBody>
-                  <a:tcPr>
-                    <a:solidFill>
-                      <a:srgbClr val="16213E"/>
-                    </a:solidFill>
-                  </a:tcPr>
-                </a:tc>
-              </a:tr>
-              <a:tr h="411480">
-                <a:tc>
-                  <a:txBody>
-                    <a:bodyPr/>
-                    <a:lstStyle/>
-                    <a:p>
-                      <a:pPr>
-                        <a:defRPr sz="1200">
-                          <a:solidFill>
-                            <a:srgbClr val="E0E0E0"/>
-                          </a:solidFill>
-                          <a:latin typeface="Lato"/>
-                        </a:defRPr>
-                      </a:pPr>
-                      <a:r>
-                        <a:t>**Path B: Terminal**</a:t>
-                      </a:r>
-                    </a:p>
-                  </a:txBody>
-                  <a:tcPr>
-                    <a:solidFill>
-                      <a:srgbClr val="1A1A2E"/>
-                    </a:solidFill>
-                  </a:tcPr>
-                </a:tc>
-                <a:tc>
-                  <a:txBody>
-                    <a:bodyPr/>
-                    <a:lstStyle/>
-                    <a:p>
-                      <a:pPr>
-                        <a:defRPr sz="1200">
-                          <a:solidFill>
-                            <a:srgbClr val="E0E0E0"/>
-                          </a:solidFill>
-                          <a:latin typeface="Lato"/>
-                        </a:defRPr>
-                      </a:pPr>
-                      <a:r>
-                        <a:t>Best performance</a:t>
-                      </a:r>
-                    </a:p>
-                  </a:txBody>
-                  <a:tcPr>
-                    <a:solidFill>
-                      <a:srgbClr val="1A1A2E"/>
-                    </a:solidFill>
-                  </a:tcPr>
-                </a:tc>
-                <a:tc>
-                  <a:txBody>
-                    <a:bodyPr/>
-                    <a:lstStyle/>
-                    <a:p>
-                      <a:pPr>
-                        <a:defRPr sz="1200">
-                          <a:solidFill>
-                            <a:srgbClr val="E0E0E0"/>
-                          </a:solidFill>
-                          <a:latin typeface="Lato"/>
-                        </a:defRPr>
-                      </a:pPr>
-                      <a:r>
-                        <a:t>15 min</a:t>
-                      </a:r>
-                    </a:p>
-                  </a:txBody>
-                  <a:tcPr>
-                    <a:solidFill>
-                      <a:srgbClr val="1A1A2E"/>
-                    </a:solidFill>
-                  </a:tcPr>
-                </a:tc>
-                <a:tc>
-                  <a:txBody>
-                    <a:bodyPr/>
-                    <a:lstStyle/>
-                    <a:p>
-                      <a:pPr>
-                        <a:defRPr sz="1200">
-                          <a:solidFill>
-                            <a:srgbClr val="E0E0E0"/>
-                          </a:solidFill>
-                          <a:latin typeface="Lato"/>
-                        </a:defRPr>
-                      </a:pPr>
-                      <a:r>
-                        <a:t>Claude in the terminal — the full power version</a:t>
-                      </a:r>
-                    </a:p>
-                  </a:txBody>
-                  <a:tcPr>
-                    <a:solidFill>
-                      <a:srgbClr val="1A1A2E"/>
-                    </a:solidFill>
-                  </a:tcPr>
-                </a:tc>
-              </a:tr>
-              <a:tr h="411480">
-                <a:tc>
-                  <a:txBody>
-                    <a:bodyPr/>
-                    <a:lstStyle/>
-                    <a:p>
-                      <a:pPr>
-                        <a:defRPr sz="1200">
-                          <a:solidFill>
-                            <a:srgbClr val="E0E0E0"/>
-                          </a:solidFill>
-                          <a:latin typeface="Lato"/>
-                        </a:defRPr>
-                      </a:pPr>
-                      <a:r>
-                        <a:t>**Path C: Desktop + Terminal**</a:t>
-                      </a:r>
-                    </a:p>
-                  </a:txBody>
-                  <a:tcPr>
-                    <a:solidFill>
-                      <a:srgbClr val="16213E"/>
-                    </a:solidFill>
-                  </a:tcPr>
-                </a:tc>
-                <a:tc>
-                  <a:txBody>
-                    <a:bodyPr/>
-                    <a:lstStyle/>
-                    <a:p>
-                      <a:pPr>
-                        <a:defRPr sz="1200">
-                          <a:solidFill>
-                            <a:srgbClr val="E0E0E0"/>
-                          </a:solidFill>
-                          <a:latin typeface="Lato"/>
-                        </a:defRPr>
-                      </a:pPr>
-                      <a:r>
-                        <a:t>Best of both worlds (RECOMMENDED)</a:t>
-                      </a:r>
-                    </a:p>
-                  </a:txBody>
-                  <a:tcPr>
-                    <a:solidFill>
-                      <a:srgbClr val="16213E"/>
-                    </a:solidFill>
-                  </a:tcPr>
-                </a:tc>
-                <a:tc>
-                  <a:txBody>
-                    <a:bodyPr/>
-                    <a:lstStyle/>
-                    <a:p>
-                      <a:pPr>
-                        <a:defRPr sz="1200">
-                          <a:solidFill>
-                            <a:srgbClr val="E0E0E0"/>
-                          </a:solidFill>
-                          <a:latin typeface="Lato"/>
-                        </a:defRPr>
-                      </a:pPr>
-                      <a:r>
-                        <a:t>10 min</a:t>
-                      </a:r>
-                    </a:p>
-                  </a:txBody>
-                  <a:tcPr>
-                    <a:solidFill>
-                      <a:srgbClr val="16213E"/>
-                    </a:solidFill>
-                  </a:tcPr>
-                </a:tc>
-                <a:tc>
-                  <a:txBody>
-                    <a:bodyPr/>
-                    <a:lstStyle/>
-                    <a:p>
-                      <a:pPr>
-                        <a:defRPr sz="1200">
-                          <a:solidFill>
-                            <a:srgbClr val="E0E0E0"/>
-                          </a:solidFill>
-                          <a:latin typeface="Lato"/>
-                        </a:defRPr>
-                      </a:pPr>
-                      <a:r>
-                        <a:t>Start with the app, it installs terminal for you</a:t>
-                      </a:r>
-                    </a:p>
-                  </a:txBody>
-                  <a:tcPr>
-                    <a:solidFill>
-                      <a:srgbClr val="16213E"/>
-                    </a:solidFill>
-                  </a:tcPr>
-                </a:tc>
-              </a:tr>
-            </a:tbl>
-          </a:graphicData>
-        </a:graphic>
-      </p:graphicFrame>
+        </p:nvSpPr>
+        <p:spPr>
+          <a:xfrm>
+            <a:off x="5181447" y="1325880"/>
+            <a:ext cx="1828800" cy="54864"/>
+          </a:xfrm>
+          <a:prstGeom prst="rect">
+            <a:avLst/>
+          </a:prstGeom>
+          <a:solidFill>
+            <a:srgbClr val="4A90D9"/>
+          </a:solidFill>
+          <a:ln>
+            <a:noFill/>
+          </a:ln>
+        </p:spPr>
+        <p:style>
+          <a:lnRef idx="1">
+            <a:schemeClr val="accent1"/>
+          </a:lnRef>
+          <a:fillRef idx="3">
+            <a:schemeClr val="accent1"/>
+          </a:fillRef>
+          <a:effectRef idx="2">
+            <a:schemeClr val="accent1"/>
+          </a:effectRef>
+          <a:fontRef idx="minor">
+            <a:schemeClr val="lt1"/>
+          </a:fontRef>
+        </p:style>
+        <p:txBody>
+          <a:bodyPr rtlCol="0" anchor="ctr"/>
+          <a:lstStyle/>
+          <a:p>
+            <a:pPr algn="ctr"/>
+          </a:p>
+        </p:txBody>
+      </p:sp>
+      <p:sp>
+        <p:nvSpPr>
+          <p:cNvPr id="4" name="TextBox 3"/>
+          <p:cNvSpPr txBox="1"/>
+          <p:nvPr/>
+        </p:nvSpPr>
+        <p:spPr>
+          <a:xfrm>
+            <a:off x="731520" y="1645920"/>
+            <a:ext cx="10728655" cy="4754880"/>
+          </a:xfrm>
+          <a:prstGeom prst="rect">
+            <a:avLst/>
+          </a:prstGeom>
+          <a:noFill/>
+        </p:spPr>
+        <p:txBody>
+          <a:bodyPr wrap="square"/>
+          <a:lstStyle/>
+          <a:p>
+            <a:pPr algn="l">
+              <a:spcAft>
+                <a:spcPts val="1200"/>
+              </a:spcAft>
+            </a:pPr>
+            <a:r>
+              <a:rPr sz="1800" b="1" i="0">
+                <a:solidFill>
+                  <a:srgbClr val="4A90D9"/>
+                </a:solidFill>
+                <a:latin typeface="Lato"/>
+              </a:rPr>
+              <a:t>1.  </a:t>
+            </a:r>
+            <a:r>
+              <a:rPr sz="1800" b="0" i="0">
+                <a:solidFill>
+                  <a:srgbClr val="E0E0E0"/>
+                </a:solidFill>
+                <a:latin typeface="Lato"/>
+              </a:rPr>
+              <a:t>Go to **warp.dev** and click **Download**</a:t>
+            </a:r>
+          </a:p>
+          <a:p>
+            <a:pPr algn="l">
+              <a:spcAft>
+                <a:spcPts val="1200"/>
+              </a:spcAft>
+            </a:pPr>
+            <a:r>
+              <a:rPr sz="1800" b="1" i="0">
+                <a:solidFill>
+                  <a:srgbClr val="4A90D9"/>
+                </a:solidFill>
+                <a:latin typeface="Lato"/>
+              </a:rPr>
+              <a:t>2.  </a:t>
+            </a:r>
+            <a:r>
+              <a:rPr sz="1800" b="0" i="0">
+                <a:solidFill>
+                  <a:srgbClr val="E0E0E0"/>
+                </a:solidFill>
+                <a:latin typeface="Lato"/>
+              </a:rPr>
+              <a:t>Open the downloaded file and follow the install prompts</a:t>
+            </a:r>
+          </a:p>
+          <a:p>
+            <a:pPr algn="l">
+              <a:spcAft>
+                <a:spcPts val="1200"/>
+              </a:spcAft>
+            </a:pPr>
+            <a:r>
+              <a:rPr sz="1800" b="1" i="0">
+                <a:solidFill>
+                  <a:srgbClr val="4A90D9"/>
+                </a:solidFill>
+                <a:latin typeface="Lato"/>
+              </a:rPr>
+              <a:t>3.  </a:t>
+            </a:r>
+            <a:r>
+              <a:rPr sz="1800" b="0" i="0">
+                <a:solidFill>
+                  <a:srgbClr val="E0E0E0"/>
+                </a:solidFill>
+                <a:latin typeface="Lato"/>
+              </a:rPr>
+              <a:t>Open **Warp** — you should see a dark window with a text box at the bottom</a:t>
+            </a:r>
+          </a:p>
+          <a:p>
+            <a:pPr algn="l">
+              <a:spcAft>
+                <a:spcPts val="1200"/>
+              </a:spcAft>
+            </a:pPr>
+            <a:r>
+              <a:rPr sz="1800" b="1" i="0">
+                <a:solidFill>
+                  <a:srgbClr val="4A90D9"/>
+                </a:solidFill>
+                <a:latin typeface="Lato"/>
+              </a:rPr>
+              <a:t>4.  </a:t>
+            </a:r>
+            <a:r>
+              <a:rPr sz="1800" b="0" i="0">
+                <a:solidFill>
+                  <a:srgbClr val="E0E0E0"/>
+                </a:solidFill>
+                <a:latin typeface="Lato"/>
+              </a:rPr>
+              <a:t>**Windows only:** click the dropdown next to the **+** tab, select **Git Bash**, then go to **Settings → Features → Session** and set Startup shell to Git Bash</a:t>
+            </a:r>
+          </a:p>
+        </p:txBody>
+      </p:sp>
     </p:spTree>
   </p:cSld>
   <p:clrMapOvr>
@@ -7958,7 +6546,7 @@
                 </a:solidFill>
                 <a:latin typeface="Lato"/>
               </a:rPr>
-              <a:t>Pick Your Path</a:t>
+              <a:t>Step 3: Pick Your Starting Point</a:t>
             </a:r>
           </a:p>
         </p:txBody>

</xml_diff>